<commit_message>
updated quadruped robot presentation slides
</commit_message>
<xml_diff>
--- a/Quadruped_Robot_Presentation.pptx
+++ b/Quadruped_Robot_Presentation.pptx
@@ -8058,7 +8058,7 @@
         <p:spPr>
           <a:xfrm>
             <a:off x="1051560" y="5449824"/>
-            <a:ext cx="4983480" cy="548640"/>
+            <a:ext cx="4983480" cy="261610"/>
           </a:xfrm>
           <a:prstGeom prst="rect">
             <a:avLst/>
@@ -8073,12 +8073,28 @@
           <a:p>
             <a:pPr algn="l"/>
             <a:r>
-              <a:rPr sz="1100" b="0" i="0">
+              <a:rPr sz="1100" b="0" i="0" dirty="0">
                 <a:solidFill>
                   <a:srgbClr val="1A1A2E"/>
                 </a:solidFill>
               </a:rPr>
-              <a:t>45 mm PETG link with servo horn connection hole at proximal end</a:t>
+              <a:t>45 mm </a:t>
+            </a:r>
+            <a:r>
+              <a:rPr lang="en-US" sz="1100" b="0" i="0" dirty="0">
+                <a:solidFill>
+                  <a:srgbClr val="1A1A2E"/>
+                </a:solidFill>
+              </a:rPr>
+              <a:t>PLA</a:t>
+            </a:r>
+            <a:r>
+              <a:rPr sz="1100" b="0" i="0" dirty="0">
+                <a:solidFill>
+                  <a:srgbClr val="1A1A2E"/>
+                </a:solidFill>
+              </a:rPr>
+              <a:t> link with servo horn connection hole at proximal end</a:t>
             </a:r>
           </a:p>
         </p:txBody>
@@ -8248,7 +8264,7 @@
         <p:spPr>
           <a:xfrm>
             <a:off x="7040880" y="1883664"/>
-            <a:ext cx="4983480" cy="548640"/>
+            <a:ext cx="4983480" cy="261610"/>
           </a:xfrm>
           <a:prstGeom prst="rect">
             <a:avLst/>
@@ -8263,12 +8279,28 @@
           <a:p>
             <a:pPr algn="l"/>
             <a:r>
-              <a:rPr sz="1100" b="0" i="0">
+              <a:rPr sz="1100" b="0" i="0" dirty="0">
                 <a:solidFill>
                   <a:srgbClr val="1A1A2E"/>
                 </a:solidFill>
               </a:rPr>
-              <a:t>55 mm PETG link with foot pad boss at distal (terminal) end</a:t>
+              <a:t>55 mm </a:t>
+            </a:r>
+            <a:r>
+              <a:rPr lang="en-US" sz="1100" b="0" i="0" dirty="0">
+                <a:solidFill>
+                  <a:srgbClr val="1A1A2E"/>
+                </a:solidFill>
+              </a:rPr>
+              <a:t>PLA</a:t>
+            </a:r>
+            <a:r>
+              <a:rPr sz="1100" b="0" i="0" dirty="0">
+                <a:solidFill>
+                  <a:srgbClr val="1A1A2E"/>
+                </a:solidFill>
+              </a:rPr>
+              <a:t> link with foot pad boss at distal (terminal) end</a:t>
             </a:r>
           </a:p>
         </p:txBody>
@@ -11154,7 +11186,7 @@
         <p:spPr>
           <a:xfrm>
             <a:off x="914400" y="5760720"/>
-            <a:ext cx="4754880" cy="548640"/>
+            <a:ext cx="4754880" cy="430887"/>
           </a:xfrm>
           <a:prstGeom prst="rect">
             <a:avLst/>
@@ -11169,13 +11201,26 @@
           <a:p>
             <a:pPr algn="l"/>
             <a:r>
-              <a:rPr sz="1100">
+              <a:rPr sz="1100" dirty="0">
                 <a:solidFill>
                   <a:srgbClr val="1A1A2E"/>
                 </a:solidFill>
               </a:rPr>
-              <a:t>3D Printer (FDM) in the CGEC Lab during fabrication of the Core Plate and Head Box using PLA+.</a:t>
-            </a:r>
+              <a:t>3D Printer (FDM) in the CGEC Lab during fabrication of the Core Plate and Head Box using </a:t>
+            </a:r>
+            <a:r>
+              <a:rPr lang="en-US" sz="1100" dirty="0">
+                <a:solidFill>
+                  <a:srgbClr val="1A1A2E"/>
+                </a:solidFill>
+              </a:rPr>
+              <a:t>ABS.</a:t>
+            </a:r>
+            <a:endParaRPr sz="1100" dirty="0">
+              <a:solidFill>
+                <a:srgbClr val="1A1A2E"/>
+              </a:solidFill>
+            </a:endParaRPr>
           </a:p>
         </p:txBody>
       </p:sp>
@@ -11195,8 +11240,8 @@
         </p:blipFill>
         <p:spPr>
           <a:xfrm>
-            <a:off x="6519672" y="1645920"/>
-            <a:ext cx="4754880" cy="3566160"/>
+            <a:off x="6492240" y="1666074"/>
+            <a:ext cx="4754880" cy="4003206"/>
           </a:xfrm>
           <a:prstGeom prst="rect">
             <a:avLst/>
@@ -11211,8 +11256,8 @@
         </p:nvSpPr>
         <p:spPr>
           <a:xfrm>
-            <a:off x="6519672" y="5303520"/>
-            <a:ext cx="4754880" cy="548640"/>
+            <a:off x="6537960" y="5760720"/>
+            <a:ext cx="4754880" cy="430887"/>
           </a:xfrm>
           <a:prstGeom prst="rect">
             <a:avLst/>
@@ -11227,8 +11272,16 @@
           <a:p>
             <a:pPr algn="l"/>
             <a:r>
-              <a:rPr sz="1100"/>
-              <a:t>Fabricated leg components (Upper and Lower leg segments) printed in magenta PETG for high layer adhesion and impact strength.</a:t>
+              <a:rPr sz="1100" dirty="0"/>
+              <a:t>Fabricated leg components (Upper and Lower leg segments) printed in magenta </a:t>
+            </a:r>
+            <a:r>
+              <a:rPr lang="en-US" sz="1100" dirty="0"/>
+              <a:t>PLA+</a:t>
+            </a:r>
+            <a:r>
+              <a:rPr sz="1100" dirty="0"/>
+              <a:t> for high layer adhesion and impact strength.</a:t>
             </a:r>
           </a:p>
         </p:txBody>
@@ -12135,7 +12188,7 @@
         <p:spPr>
           <a:xfrm>
             <a:off x="1883664" y="1984248"/>
-            <a:ext cx="1280160" cy="640080"/>
+            <a:ext cx="1280160" cy="276999"/>
           </a:xfrm>
           <a:prstGeom prst="rect">
             <a:avLst/>
@@ -12150,13 +12203,18 @@
           <a:p>
             <a:pPr algn="l"/>
             <a:r>
-              <a:rPr sz="1200" b="0" i="0">
+              <a:rPr lang="en-US" sz="1200" b="0" i="0" dirty="0">
                 <a:solidFill>
                   <a:srgbClr val="C02020"/>
                 </a:solidFill>
               </a:rPr>
-              <a:t>PLA+</a:t>
-            </a:r>
+              <a:t>ABS</a:t>
+            </a:r>
+            <a:endParaRPr sz="1200" b="0" i="0" dirty="0">
+              <a:solidFill>
+                <a:srgbClr val="C02020"/>
+              </a:solidFill>
+            </a:endParaRPr>
           </a:p>
         </p:txBody>
       </p:sp>
@@ -12525,7 +12583,7 @@
         <p:spPr>
           <a:xfrm>
             <a:off x="1883664" y="2852927"/>
-            <a:ext cx="1280160" cy="640080"/>
+            <a:ext cx="1280160" cy="276999"/>
           </a:xfrm>
           <a:prstGeom prst="rect">
             <a:avLst/>
@@ -12540,13 +12598,18 @@
           <a:p>
             <a:pPr algn="l"/>
             <a:r>
-              <a:rPr sz="1200" b="0" i="0">
+              <a:rPr lang="en-US" sz="1200" b="0" i="0" dirty="0">
                 <a:solidFill>
                   <a:srgbClr val="C02020"/>
                 </a:solidFill>
               </a:rPr>
-              <a:t>PLA+</a:t>
-            </a:r>
+              <a:t>ABS</a:t>
+            </a:r>
+            <a:endParaRPr sz="1200" b="0" i="0" dirty="0">
+              <a:solidFill>
+                <a:srgbClr val="C02020"/>
+              </a:solidFill>
+            </a:endParaRPr>
           </a:p>
         </p:txBody>
       </p:sp>
@@ -12915,7 +12978,7 @@
         <p:spPr>
           <a:xfrm>
             <a:off x="1883664" y="3721607"/>
-            <a:ext cx="1280160" cy="640080"/>
+            <a:ext cx="1280160" cy="276999"/>
           </a:xfrm>
           <a:prstGeom prst="rect">
             <a:avLst/>
@@ -12930,13 +12993,18 @@
           <a:p>
             <a:pPr algn="l"/>
             <a:r>
-              <a:rPr sz="1200" b="0" i="0">
+              <a:rPr lang="en-US" sz="1200" b="0" i="0" dirty="0">
                 <a:solidFill>
                   <a:srgbClr val="176B47"/>
                 </a:solidFill>
               </a:rPr>
-              <a:t>PETG</a:t>
-            </a:r>
+              <a:t>PLA+</a:t>
+            </a:r>
+            <a:endParaRPr sz="1200" b="0" i="0" dirty="0">
+              <a:solidFill>
+                <a:srgbClr val="176B47"/>
+              </a:solidFill>
+            </a:endParaRPr>
           </a:p>
         </p:txBody>
       </p:sp>
@@ -13305,7 +13373,7 @@
         <p:spPr>
           <a:xfrm>
             <a:off x="1883664" y="4590288"/>
-            <a:ext cx="1280160" cy="640080"/>
+            <a:ext cx="1280160" cy="276999"/>
           </a:xfrm>
           <a:prstGeom prst="rect">
             <a:avLst/>
@@ -13320,13 +13388,18 @@
           <a:p>
             <a:pPr algn="l"/>
             <a:r>
-              <a:rPr sz="1200" b="0" i="0">
+              <a:rPr lang="en-US" sz="1200" b="0" i="0" dirty="0">
                 <a:solidFill>
                   <a:srgbClr val="176B47"/>
                 </a:solidFill>
               </a:rPr>
-              <a:t>PETG</a:t>
-            </a:r>
+              <a:t>PLA+</a:t>
+            </a:r>
+            <a:endParaRPr sz="1200" b="0" i="0" dirty="0">
+              <a:solidFill>
+                <a:srgbClr val="176B47"/>
+              </a:solidFill>
+            </a:endParaRPr>
           </a:p>
         </p:txBody>
       </p:sp>
@@ -13695,7 +13768,7 @@
         <p:spPr>
           <a:xfrm>
             <a:off x="1883664" y="5458967"/>
-            <a:ext cx="1280160" cy="640080"/>
+            <a:ext cx="1280160" cy="276999"/>
           </a:xfrm>
           <a:prstGeom prst="rect">
             <a:avLst/>
@@ -13710,13 +13783,18 @@
           <a:p>
             <a:pPr algn="l"/>
             <a:r>
-              <a:rPr sz="1200" b="0" i="0">
+              <a:rPr lang="en-US" sz="1200" b="0" i="0" dirty="0">
                 <a:solidFill>
                   <a:srgbClr val="C02020"/>
                 </a:solidFill>
               </a:rPr>
-              <a:t>PLA+</a:t>
-            </a:r>
+              <a:t>ABS</a:t>
+            </a:r>
+            <a:endParaRPr sz="1200" b="0" i="0" dirty="0">
+              <a:solidFill>
+                <a:srgbClr val="C02020"/>
+              </a:solidFill>
+            </a:endParaRPr>
           </a:p>
         </p:txBody>
       </p:sp>
@@ -15655,6 +15733,7 @@
                 <a:solidFill>
                   <a:srgbClr val="6A9F55"/>
                 </a:solidFill>
+                <a:latin typeface="Consolas"/>
               </a:rPr>
               <a:t>// Servo Test Code — ESP32 direct GPIO18</a:t>
             </a:r>
@@ -15689,6 +15768,7 @@
                 <a:solidFill>
                   <a:srgbClr val="C5786B"/>
                 </a:solidFill>
+                <a:latin typeface="Consolas"/>
               </a:rPr>
               <a:t>#include &lt;ESP32Servo.h&gt;</a:t>
             </a:r>
@@ -15750,6 +15830,7 @@
                 <a:solidFill>
                   <a:srgbClr val="9CCBFF"/>
                 </a:solidFill>
+                <a:latin typeface="Consolas"/>
               </a:rPr>
               <a:t>Servo myServo;</a:t>
             </a:r>
@@ -15811,6 +15892,7 @@
                 <a:solidFill>
                   <a:srgbClr val="DDDDAA"/>
                 </a:solidFill>
+                <a:latin typeface="Consolas"/>
               </a:rPr>
               <a:t>void setup() {</a:t>
             </a:r>
@@ -15845,6 +15927,7 @@
                 <a:solidFill>
                   <a:srgbClr val="CCCCCC"/>
                 </a:solidFill>
+                <a:latin typeface="Consolas"/>
               </a:rPr>
               <a:t>  myServo.attach(18);  // GPIO18</a:t>
             </a:r>
@@ -15879,6 +15962,7 @@
                 <a:solidFill>
                   <a:srgbClr val="DDDDAA"/>
                 </a:solidFill>
+                <a:latin typeface="Consolas"/>
               </a:rPr>
               <a:t>}</a:t>
             </a:r>
@@ -15940,6 +16024,7 @@
                 <a:solidFill>
                   <a:srgbClr val="DDDDAA"/>
                 </a:solidFill>
+                <a:latin typeface="Consolas"/>
               </a:rPr>
               <a:t>void loop() {</a:t>
             </a:r>
@@ -15974,6 +16059,7 @@
                 <a:solidFill>
                   <a:srgbClr val="CCCCCC"/>
                 </a:solidFill>
+                <a:latin typeface="Consolas"/>
               </a:rPr>
               <a:t>  myServo.write(0);    delay(1000);</a:t>
             </a:r>
@@ -16008,6 +16094,7 @@
                 <a:solidFill>
                   <a:srgbClr val="CCCCCC"/>
                 </a:solidFill>
+                <a:latin typeface="Consolas"/>
               </a:rPr>
               <a:t>  myServo.write(90);   delay(1000);</a:t>
             </a:r>
@@ -16038,12 +16125,31 @@
           <a:p>
             <a:pPr algn="l"/>
             <a:r>
-              <a:rPr sz="1100" b="0" i="0">
+              <a:rPr sz="1100" b="0" i="0" dirty="0">
                 <a:solidFill>
                   <a:srgbClr val="CCCCCC"/>
                 </a:solidFill>
-              </a:rPr>
-              <a:t>  myServo.write(180);  delay(1000);</a:t>
+                <a:latin typeface="Consolas"/>
+              </a:rPr>
+              <a:t>  </a:t>
+            </a:r>
+            <a:r>
+              <a:rPr sz="1100" b="0" i="0" dirty="0" err="1">
+                <a:solidFill>
+                  <a:srgbClr val="CCCCCC"/>
+                </a:solidFill>
+                <a:latin typeface="Consolas"/>
+              </a:rPr>
+              <a:t>myServo.write</a:t>
+            </a:r>
+            <a:r>
+              <a:rPr sz="1100" b="0" i="0" dirty="0">
+                <a:solidFill>
+                  <a:srgbClr val="CCCCCC"/>
+                </a:solidFill>
+                <a:latin typeface="Consolas"/>
+              </a:rPr>
+              <a:t>(180);  delay(1000);</a:t>
             </a:r>
           </a:p>
         </p:txBody>
@@ -16076,6 +16182,7 @@
                 <a:solidFill>
                   <a:srgbClr val="DDDDAA"/>
                 </a:solidFill>
+                <a:latin typeface="Consolas"/>
               </a:rPr>
               <a:t>}</a:t>
             </a:r>
@@ -23406,7 +23513,39 @@
                   <a:srgbClr val="1A1A2E"/>
                 </a:solidFill>
               </a:rPr>
-              <a:t>Hands-on material selection (PLA+ vs PETG), slicer optimization, and print quality assessment in CGEC Lab</a:t>
+              <a:t>Hands-on material selection (PLA+</a:t>
+            </a:r>
+            <a:r>
+              <a:rPr lang="en-US" sz="1400" b="0" i="0" dirty="0">
+                <a:solidFill>
+                  <a:srgbClr val="1A1A2E"/>
+                </a:solidFill>
+              </a:rPr>
+              <a:t>, </a:t>
+            </a:r>
+            <a:r>
+              <a:rPr sz="1400" b="0" i="0" dirty="0">
+                <a:solidFill>
+                  <a:srgbClr val="1A1A2E"/>
+                </a:solidFill>
+              </a:rPr>
+              <a:t>PETG</a:t>
+            </a:r>
+            <a:r>
+              <a:rPr lang="en-US" sz="1400" b="0" i="0" dirty="0">
+                <a:solidFill>
+                  <a:srgbClr val="1A1A2E"/>
+                </a:solidFill>
+              </a:rPr>
+              <a:t> &amp; ABS</a:t>
+            </a:r>
+            <a:r>
+              <a:rPr sz="1400" b="0" i="0" dirty="0">
+                <a:solidFill>
+                  <a:srgbClr val="1A1A2E"/>
+                </a:solidFill>
+              </a:rPr>
+              <a:t>), slicer optimization, and print quality assessment in CGEC Lab</a:t>
             </a:r>
           </a:p>
         </p:txBody>

</xml_diff>

<commit_message>
fix(3D_REPORT): correct material specifications and remove head rotation references
- Change PLA+ references to PLA for core structural components
- Change PETG references to ABS for leg components and engineering filaments
- Remove CH8 head servo channel from servo mapping and wiring diagram
- Remove head rotation DOF reference from project objectives
- Remove head servo mount from core plate specifications
- Update robot top-view diagram to remove head servo positioning
- Correct spacing and formatting inconsistencies throughout document
- Align material specifications with actual fabrication approach
</commit_message>
<xml_diff>
--- a/Quadruped_Robot_Presentation.pptx
+++ b/Quadruped_Robot_Presentation.pptx
@@ -3977,23 +3977,23 @@
         </p:nvSpPr>
         <p:spPr>
           <a:xfrm>
-            <a:off x="384048" y="1572768"/>
-            <a:ext cx="2176272" cy="512064"/>
-          </a:xfrm>
-          <a:prstGeom prst="rect">
-            <a:avLst/>
-          </a:prstGeom>
-          <a:noFill/>
-        </p:spPr>
-        <p:txBody>
-          <a:bodyPr wrap="square">
-            <a:spAutoFit/>
-          </a:bodyPr>
-          <a:lstStyle/>
-          <a:p>
-            <a:pPr algn="ctr"/>
-            <a:r>
-              <a:rPr sz="1300" b="1" i="0">
+            <a:off x="384048" y="1665905"/>
+            <a:ext cx="2176272" cy="307777"/>
+          </a:xfrm>
+          <a:prstGeom prst="rect">
+            <a:avLst/>
+          </a:prstGeom>
+          <a:noFill/>
+        </p:spPr>
+        <p:txBody>
+          <a:bodyPr wrap="square">
+            <a:spAutoFit/>
+          </a:bodyPr>
+          <a:lstStyle/>
+          <a:p>
+            <a:pPr algn="ctr"/>
+            <a:r>
+              <a:rPr sz="1400" b="1" i="0" dirty="0">
                 <a:solidFill>
                   <a:srgbClr val="FFFFFF"/>
                 </a:solidFill>
@@ -4055,8 +4055,8 @@
         </p:nvSpPr>
         <p:spPr>
           <a:xfrm>
-            <a:off x="2743200" y="1517904"/>
-            <a:ext cx="9006840" cy="621792"/>
+            <a:off x="2743200" y="1670310"/>
+            <a:ext cx="9006840" cy="292388"/>
           </a:xfrm>
           <a:prstGeom prst="rect">
             <a:avLst/>
@@ -4071,12 +4071,28 @@
           <a:p>
             <a:pPr algn="l"/>
             <a:r>
-              <a:rPr sz="1300" b="0" i="0">
+              <a:rPr sz="1300" b="0" i="0" dirty="0">
                 <a:solidFill>
                   <a:srgbClr val="1A1A2E"/>
                 </a:solidFill>
               </a:rPr>
-              <a:t>All 9 servos were completely unresponsive when controlled via PCA9685</a:t>
+              <a:t>All </a:t>
+            </a:r>
+            <a:r>
+              <a:rPr lang="en-US" sz="1300" b="0" i="0" dirty="0">
+                <a:solidFill>
+                  <a:srgbClr val="1A1A2E"/>
+                </a:solidFill>
+              </a:rPr>
+              <a:t>8</a:t>
+            </a:r>
+            <a:r>
+              <a:rPr sz="1300" b="0" i="0" dirty="0">
+                <a:solidFill>
+                  <a:srgbClr val="1A1A2E"/>
+                </a:solidFill>
+              </a:rPr>
+              <a:t> servos were completely unresponsive when controlled via PCA9685</a:t>
             </a:r>
           </a:p>
         </p:txBody>
@@ -4133,23 +4149,23 @@
         </p:nvSpPr>
         <p:spPr>
           <a:xfrm>
-            <a:off x="384048" y="2468880"/>
-            <a:ext cx="2176272" cy="512064"/>
-          </a:xfrm>
-          <a:prstGeom prst="rect">
-            <a:avLst/>
-          </a:prstGeom>
-          <a:noFill/>
-        </p:spPr>
-        <p:txBody>
-          <a:bodyPr wrap="square">
-            <a:spAutoFit/>
-          </a:bodyPr>
-          <a:lstStyle/>
-          <a:p>
-            <a:pPr algn="ctr"/>
-            <a:r>
-              <a:rPr sz="1300" b="1" i="0">
+            <a:off x="384048" y="2562017"/>
+            <a:ext cx="2176272" cy="307777"/>
+          </a:xfrm>
+          <a:prstGeom prst="rect">
+            <a:avLst/>
+          </a:prstGeom>
+          <a:noFill/>
+        </p:spPr>
+        <p:txBody>
+          <a:bodyPr wrap="square">
+            <a:spAutoFit/>
+          </a:bodyPr>
+          <a:lstStyle/>
+          <a:p>
+            <a:pPr algn="ctr"/>
+            <a:r>
+              <a:rPr sz="1400" b="1" i="0">
                 <a:solidFill>
                   <a:srgbClr val="FFFFFF"/>
                 </a:solidFill>
@@ -4211,7 +4227,7 @@
         </p:nvSpPr>
         <p:spPr>
           <a:xfrm>
-            <a:off x="2743200" y="2414016"/>
+            <a:off x="2743200" y="2566422"/>
             <a:ext cx="9006840" cy="621792"/>
           </a:xfrm>
           <a:prstGeom prst="rect">
@@ -4289,23 +4305,23 @@
         </p:nvSpPr>
         <p:spPr>
           <a:xfrm>
-            <a:off x="384048" y="3364992"/>
-            <a:ext cx="2176272" cy="512064"/>
-          </a:xfrm>
-          <a:prstGeom prst="rect">
-            <a:avLst/>
-          </a:prstGeom>
-          <a:noFill/>
-        </p:spPr>
-        <p:txBody>
-          <a:bodyPr wrap="square">
-            <a:spAutoFit/>
-          </a:bodyPr>
-          <a:lstStyle/>
-          <a:p>
-            <a:pPr algn="ctr"/>
-            <a:r>
-              <a:rPr sz="1300" b="1" i="0">
+            <a:off x="384048" y="3458129"/>
+            <a:ext cx="2176272" cy="307777"/>
+          </a:xfrm>
+          <a:prstGeom prst="rect">
+            <a:avLst/>
+          </a:prstGeom>
+          <a:noFill/>
+        </p:spPr>
+        <p:txBody>
+          <a:bodyPr wrap="square">
+            <a:spAutoFit/>
+          </a:bodyPr>
+          <a:lstStyle/>
+          <a:p>
+            <a:pPr algn="ctr"/>
+            <a:r>
+              <a:rPr sz="1400" b="1" i="0">
                 <a:solidFill>
                   <a:srgbClr val="FFFFFF"/>
                 </a:solidFill>
@@ -4367,7 +4383,7 @@
         </p:nvSpPr>
         <p:spPr>
           <a:xfrm>
-            <a:off x="2743200" y="3310128"/>
+            <a:off x="2743200" y="3462534"/>
             <a:ext cx="9006840" cy="621792"/>
           </a:xfrm>
           <a:prstGeom prst="rect">
@@ -4445,23 +4461,23 @@
         </p:nvSpPr>
         <p:spPr>
           <a:xfrm>
-            <a:off x="384048" y="4261103"/>
-            <a:ext cx="2176272" cy="512064"/>
-          </a:xfrm>
-          <a:prstGeom prst="rect">
-            <a:avLst/>
-          </a:prstGeom>
-          <a:noFill/>
-        </p:spPr>
-        <p:txBody>
-          <a:bodyPr wrap="square">
-            <a:spAutoFit/>
-          </a:bodyPr>
-          <a:lstStyle/>
-          <a:p>
-            <a:pPr algn="ctr"/>
-            <a:r>
-              <a:rPr sz="1300" b="1" i="0">
+            <a:off x="384048" y="4354240"/>
+            <a:ext cx="2176272" cy="307777"/>
+          </a:xfrm>
+          <a:prstGeom prst="rect">
+            <a:avLst/>
+          </a:prstGeom>
+          <a:noFill/>
+        </p:spPr>
+        <p:txBody>
+          <a:bodyPr wrap="square">
+            <a:spAutoFit/>
+          </a:bodyPr>
+          <a:lstStyle/>
+          <a:p>
+            <a:pPr algn="ctr"/>
+            <a:r>
+              <a:rPr sz="1400" b="1" i="0">
                 <a:solidFill>
                   <a:srgbClr val="FFFFFF"/>
                 </a:solidFill>
@@ -4523,7 +4539,7 @@
         </p:nvSpPr>
         <p:spPr>
           <a:xfrm>
-            <a:off x="2743200" y="4206240"/>
+            <a:off x="2743200" y="4358646"/>
             <a:ext cx="9006840" cy="621792"/>
           </a:xfrm>
           <a:prstGeom prst="rect">
@@ -4601,23 +4617,23 @@
         </p:nvSpPr>
         <p:spPr>
           <a:xfrm>
-            <a:off x="384048" y="5157216"/>
-            <a:ext cx="2176272" cy="512064"/>
-          </a:xfrm>
-          <a:prstGeom prst="rect">
-            <a:avLst/>
-          </a:prstGeom>
-          <a:noFill/>
-        </p:spPr>
-        <p:txBody>
-          <a:bodyPr wrap="square">
-            <a:spAutoFit/>
-          </a:bodyPr>
-          <a:lstStyle/>
-          <a:p>
-            <a:pPr algn="ctr"/>
-            <a:r>
-              <a:rPr sz="1300" b="1" i="0">
+            <a:off x="384048" y="5250353"/>
+            <a:ext cx="2176272" cy="307777"/>
+          </a:xfrm>
+          <a:prstGeom prst="rect">
+            <a:avLst/>
+          </a:prstGeom>
+          <a:noFill/>
+        </p:spPr>
+        <p:txBody>
+          <a:bodyPr wrap="square">
+            <a:spAutoFit/>
+          </a:bodyPr>
+          <a:lstStyle/>
+          <a:p>
+            <a:pPr algn="ctr"/>
+            <a:r>
+              <a:rPr sz="1400" b="1" i="0" dirty="0">
                 <a:solidFill>
                   <a:srgbClr val="FFFFFF"/>
                 </a:solidFill>
@@ -4679,7 +4695,7 @@
         </p:nvSpPr>
         <p:spPr>
           <a:xfrm>
-            <a:off x="2743200" y="5102352"/>
+            <a:off x="2743200" y="5254758"/>
             <a:ext cx="9006840" cy="621792"/>
           </a:xfrm>
           <a:prstGeom prst="rect">
@@ -5207,7 +5223,7 @@
         <p:spPr>
           <a:xfrm>
             <a:off x="731520" y="1874519"/>
-            <a:ext cx="5120640" cy="384048"/>
+            <a:ext cx="5120640" cy="461665"/>
           </a:xfrm>
           <a:prstGeom prst="rect">
             <a:avLst/>
@@ -5222,12 +5238,28 @@
           <a:p>
             <a:pPr algn="l"/>
             <a:r>
-              <a:rPr sz="1200" b="0" i="0">
+              <a:rPr sz="1200" b="0" i="0" dirty="0">
                 <a:solidFill>
                   <a:srgbClr val="1A1A2E"/>
                 </a:solidFill>
               </a:rPr>
-              <a:t>Two main assemblies: Head Box (electronics enclosure) + Core Plate (central chassis)</a:t>
+              <a:t>Two main assemblies: Head Box (electronics enclosure) + </a:t>
+            </a:r>
+            <a:r>
+              <a:rPr lang="en-IN" sz="1200" b="0" i="0" dirty="0">
+                <a:solidFill>
+                  <a:srgbClr val="1A1A2E"/>
+                </a:solidFill>
+              </a:rPr>
+              <a:t>Core Body</a:t>
+            </a:r>
+            <a:r>
+              <a:rPr sz="1200" b="0" i="0" dirty="0">
+                <a:solidFill>
+                  <a:srgbClr val="1A1A2E"/>
+                </a:solidFill>
+              </a:rPr>
+              <a:t> (central chassis)</a:t>
             </a:r>
           </a:p>
         </p:txBody>
@@ -5343,7 +5375,7 @@
         <p:spPr>
           <a:xfrm>
             <a:off x="731520" y="2697479"/>
-            <a:ext cx="5120640" cy="384048"/>
+            <a:ext cx="5120640" cy="276999"/>
           </a:xfrm>
           <a:prstGeom prst="rect">
             <a:avLst/>
@@ -5358,12 +5390,36 @@
           <a:p>
             <a:pPr algn="l"/>
             <a:r>
-              <a:rPr sz="1200" b="0" i="0">
+              <a:rPr lang="en-IN" sz="1200" b="0" i="0" dirty="0">
                 <a:solidFill>
                   <a:srgbClr val="1A1A2E"/>
                 </a:solidFill>
               </a:rPr>
-              <a:t>Core Plate — mounts all 4 hip servos + 1 head servo (5 total on chassis)</a:t>
+              <a:t>Core Body</a:t>
+            </a:r>
+            <a:r>
+              <a:rPr sz="1200" b="0" i="0" dirty="0">
+                <a:solidFill>
+                  <a:srgbClr val="1A1A2E"/>
+                </a:solidFill>
+              </a:rPr>
+              <a:t> — mounts all 4 hip servos (</a:t>
+            </a:r>
+            <a:r>
+              <a:rPr lang="en-US" sz="1200" b="0" i="0" dirty="0">
+                <a:solidFill>
+                  <a:srgbClr val="1A1A2E"/>
+                </a:solidFill>
+              </a:rPr>
+              <a:t>4</a:t>
+            </a:r>
+            <a:r>
+              <a:rPr sz="1200" b="0" i="0" dirty="0">
+                <a:solidFill>
+                  <a:srgbClr val="1A1A2E"/>
+                </a:solidFill>
+              </a:rPr>
+              <a:t> total on chassis)</a:t>
             </a:r>
           </a:p>
         </p:txBody>
@@ -5801,7 +5857,7 @@
         <p:spPr>
           <a:xfrm>
             <a:off x="6272783" y="2322576"/>
-            <a:ext cx="1874519" cy="310896"/>
+            <a:ext cx="1874519" cy="261610"/>
           </a:xfrm>
           <a:prstGeom prst="rect">
             <a:avLst/>
@@ -5816,13 +5872,18 @@
           <a:p>
             <a:pPr algn="l"/>
             <a:r>
-              <a:rPr sz="1100" b="0" i="0">
+              <a:rPr lang="en-IN" sz="1100" b="0" i="0" dirty="0">
                 <a:solidFill>
                   <a:srgbClr val="1A1A2E"/>
                 </a:solidFill>
               </a:rPr>
-              <a:t>Core Plate</a:t>
-            </a:r>
+              <a:t>Core Body</a:t>
+            </a:r>
+            <a:endParaRPr sz="1100" b="0" i="0" dirty="0">
+              <a:solidFill>
+                <a:srgbClr val="1A1A2E"/>
+              </a:solidFill>
+            </a:endParaRPr>
           </a:p>
         </p:txBody>
       </p:sp>
@@ -5977,8 +6038,21 @@
                   <a:srgbClr val="1A1A2E"/>
                 </a:solidFill>
               </a:rPr>
-              <a:t>4 hip mounts + 1 head servo</a:t>
-            </a:r>
+              <a:t>4 hip mount</a:t>
+            </a:r>
+            <a:r>
+              <a:rPr lang="en-IN" sz="1100" b="0" i="0" dirty="0">
+                <a:solidFill>
+                  <a:srgbClr val="1A1A2E"/>
+                </a:solidFill>
+              </a:rPr>
+              <a:t>s</a:t>
+            </a:r>
+            <a:endParaRPr sz="1100" b="0" i="0" dirty="0">
+              <a:solidFill>
+                <a:srgbClr val="1A1A2E"/>
+              </a:solidFill>
+            </a:endParaRPr>
           </a:p>
         </p:txBody>
       </p:sp>
@@ -6050,7 +6124,7 @@
           <a:p>
             <a:pPr algn="l"/>
             <a:r>
-              <a:rPr sz="1100" b="0" i="0">
+              <a:rPr sz="1100" b="0" i="0" dirty="0">
                 <a:solidFill>
                   <a:srgbClr val="1A1A2E"/>
                 </a:solidFill>
@@ -6440,12 +6514,20 @@
           <a:p>
             <a:pPr algn="l"/>
             <a:r>
-              <a:rPr sz="1100" b="0" i="0">
+              <a:rPr lang="en-IN" sz="1100" b="0" i="0" dirty="0">
                 <a:solidFill>
                   <a:srgbClr val="1A1A2E"/>
                 </a:solidFill>
               </a:rPr>
-              <a:t>PETG — hip servo driven</a:t>
+              <a:t>PLA+</a:t>
+            </a:r>
+            <a:r>
+              <a:rPr sz="1100" b="0" i="0" dirty="0">
+                <a:solidFill>
+                  <a:srgbClr val="1A1A2E"/>
+                </a:solidFill>
+              </a:rPr>
+              <a:t> — hip servo driven</a:t>
             </a:r>
           </a:p>
         </p:txBody>
@@ -6674,246 +6756,20 @@
           <a:p>
             <a:pPr algn="l"/>
             <a:r>
-              <a:rPr sz="1100" b="0" i="0">
+              <a:rPr lang="en-IN" sz="1100" dirty="0">
                 <a:solidFill>
                   <a:srgbClr val="1A1A2E"/>
                 </a:solidFill>
               </a:rPr>
-              <a:t>PETG — knee servo driven</a:t>
-            </a:r>
-          </a:p>
-        </p:txBody>
-      </p:sp>
-      <p:sp>
-        <p:nvSpPr>
-          <p:cNvPr id="53" name="Rectangle 52"/>
-          <p:cNvSpPr/>
-          <p:nvPr/>
-        </p:nvSpPr>
-        <p:spPr>
-          <a:xfrm>
-            <a:off x="6217920" y="3995927"/>
-            <a:ext cx="1965960" cy="402336"/>
-          </a:xfrm>
-          <a:prstGeom prst="rect">
-            <a:avLst/>
-          </a:prstGeom>
-          <a:solidFill>
-            <a:srgbClr val="FFFFFF"/>
-          </a:solidFill>
-          <a:ln>
-            <a:noFill/>
-          </a:ln>
-        </p:spPr>
-        <p:style>
-          <a:lnRef idx="1">
-            <a:schemeClr val="accent1"/>
-          </a:lnRef>
-          <a:fillRef idx="3">
-            <a:schemeClr val="accent1"/>
-          </a:fillRef>
-          <a:effectRef idx="2">
-            <a:schemeClr val="accent1"/>
-          </a:effectRef>
-          <a:fontRef idx="minor">
-            <a:schemeClr val="lt1"/>
-          </a:fontRef>
-        </p:style>
-        <p:txBody>
-          <a:bodyPr rtlCol="0" anchor="ctr"/>
-          <a:lstStyle/>
-          <a:p>
-            <a:pPr algn="ctr"/>
-            <a:endParaRPr/>
-          </a:p>
-        </p:txBody>
-      </p:sp>
-      <p:sp>
-        <p:nvSpPr>
-          <p:cNvPr id="54" name="TextBox 53"/>
-          <p:cNvSpPr txBox="1"/>
-          <p:nvPr/>
-        </p:nvSpPr>
-        <p:spPr>
-          <a:xfrm>
-            <a:off x="6272783" y="4041647"/>
-            <a:ext cx="1874519" cy="310896"/>
-          </a:xfrm>
-          <a:prstGeom prst="rect">
-            <a:avLst/>
-          </a:prstGeom>
-          <a:noFill/>
-        </p:spPr>
-        <p:txBody>
-          <a:bodyPr wrap="square">
-            <a:spAutoFit/>
-          </a:bodyPr>
-          <a:lstStyle/>
-          <a:p>
-            <a:pPr algn="l"/>
-            <a:r>
-              <a:rPr sz="1100" b="0" i="0">
+              <a:t>PLA+</a:t>
+            </a:r>
+            <a:r>
+              <a:rPr sz="1100" b="0" i="0" dirty="0">
                 <a:solidFill>
                   <a:srgbClr val="1A1A2E"/>
                 </a:solidFill>
               </a:rPr>
-              <a:t>Servo Mount×9</a:t>
-            </a:r>
-          </a:p>
-        </p:txBody>
-      </p:sp>
-      <p:sp>
-        <p:nvSpPr>
-          <p:cNvPr id="55" name="Rectangle 54"/>
-          <p:cNvSpPr/>
-          <p:nvPr/>
-        </p:nvSpPr>
-        <p:spPr>
-          <a:xfrm>
-            <a:off x="8229600" y="3995927"/>
-            <a:ext cx="1600200" cy="402336"/>
-          </a:xfrm>
-          <a:prstGeom prst="rect">
-            <a:avLst/>
-          </a:prstGeom>
-          <a:solidFill>
-            <a:srgbClr val="FFFFFF"/>
-          </a:solidFill>
-          <a:ln>
-            <a:noFill/>
-          </a:ln>
-        </p:spPr>
-        <p:style>
-          <a:lnRef idx="1">
-            <a:schemeClr val="accent1"/>
-          </a:lnRef>
-          <a:fillRef idx="3">
-            <a:schemeClr val="accent1"/>
-          </a:fillRef>
-          <a:effectRef idx="2">
-            <a:schemeClr val="accent1"/>
-          </a:effectRef>
-          <a:fontRef idx="minor">
-            <a:schemeClr val="lt1"/>
-          </a:fontRef>
-        </p:style>
-        <p:txBody>
-          <a:bodyPr rtlCol="0" anchor="ctr"/>
-          <a:lstStyle/>
-          <a:p>
-            <a:pPr algn="ctr"/>
-            <a:endParaRPr/>
-          </a:p>
-        </p:txBody>
-      </p:sp>
-      <p:sp>
-        <p:nvSpPr>
-          <p:cNvPr id="56" name="TextBox 55"/>
-          <p:cNvSpPr txBox="1"/>
-          <p:nvPr/>
-        </p:nvSpPr>
-        <p:spPr>
-          <a:xfrm>
-            <a:off x="8284464" y="4041647"/>
-            <a:ext cx="1508760" cy="310896"/>
-          </a:xfrm>
-          <a:prstGeom prst="rect">
-            <a:avLst/>
-          </a:prstGeom>
-          <a:noFill/>
-        </p:spPr>
-        <p:txBody>
-          <a:bodyPr wrap="square">
-            <a:spAutoFit/>
-          </a:bodyPr>
-          <a:lstStyle/>
-          <a:p>
-            <a:pPr algn="l"/>
-            <a:r>
-              <a:rPr sz="1100" b="0" i="0">
-                <a:solidFill>
-                  <a:srgbClr val="1A1A2E"/>
-                </a:solidFill>
-              </a:rPr>
-              <a:t>Custom press-fit</a:t>
-            </a:r>
-          </a:p>
-        </p:txBody>
-      </p:sp>
-      <p:sp>
-        <p:nvSpPr>
-          <p:cNvPr id="57" name="Rectangle 56"/>
-          <p:cNvSpPr/>
-          <p:nvPr/>
-        </p:nvSpPr>
-        <p:spPr>
-          <a:xfrm>
-            <a:off x="9875520" y="3995927"/>
-            <a:ext cx="2086325" cy="402336"/>
-          </a:xfrm>
-          <a:prstGeom prst="rect">
-            <a:avLst/>
-          </a:prstGeom>
-          <a:solidFill>
-            <a:srgbClr val="FFFFFF"/>
-          </a:solidFill>
-          <a:ln>
-            <a:noFill/>
-          </a:ln>
-        </p:spPr>
-        <p:style>
-          <a:lnRef idx="1">
-            <a:schemeClr val="accent1"/>
-          </a:lnRef>
-          <a:fillRef idx="3">
-            <a:schemeClr val="accent1"/>
-          </a:fillRef>
-          <a:effectRef idx="2">
-            <a:schemeClr val="accent1"/>
-          </a:effectRef>
-          <a:fontRef idx="minor">
-            <a:schemeClr val="lt1"/>
-          </a:fontRef>
-        </p:style>
-        <p:txBody>
-          <a:bodyPr rtlCol="0" anchor="ctr"/>
-          <a:lstStyle/>
-          <a:p>
-            <a:pPr algn="ctr"/>
-            <a:endParaRPr/>
-          </a:p>
-        </p:txBody>
-      </p:sp>
-      <p:sp>
-        <p:nvSpPr>
-          <p:cNvPr id="58" name="TextBox 57"/>
-          <p:cNvSpPr txBox="1"/>
-          <p:nvPr/>
-        </p:nvSpPr>
-        <p:spPr>
-          <a:xfrm>
-            <a:off x="9930384" y="4041647"/>
-            <a:ext cx="1883664" cy="261610"/>
-          </a:xfrm>
-          <a:prstGeom prst="rect">
-            <a:avLst/>
-          </a:prstGeom>
-          <a:noFill/>
-        </p:spPr>
-        <p:txBody>
-          <a:bodyPr wrap="square">
-            <a:spAutoFit/>
-          </a:bodyPr>
-          <a:lstStyle/>
-          <a:p>
-            <a:pPr algn="l"/>
-            <a:r>
-              <a:rPr sz="1100" b="0" i="0">
-                <a:solidFill>
-                  <a:srgbClr val="1A1A2E"/>
-                </a:solidFill>
-              </a:rPr>
-              <a:t>PLA+ — MG90S body fit</a:t>
+              <a:t> — knee servo driven</a:t>
             </a:r>
           </a:p>
         </p:txBody>
@@ -7454,7 +7310,7 @@
         <p:spPr>
           <a:xfrm>
             <a:off x="1051560" y="1517904"/>
-            <a:ext cx="4983480" cy="347472"/>
+            <a:ext cx="4983480" cy="292388"/>
           </a:xfrm>
           <a:prstGeom prst="rect">
             <a:avLst/>
@@ -7469,13 +7325,18 @@
           <a:p>
             <a:pPr algn="l"/>
             <a:r>
-              <a:rPr sz="1300" b="1" i="0">
+              <a:rPr lang="en-IN" sz="1300" b="1" i="0" dirty="0">
                 <a:solidFill>
                   <a:srgbClr val="0D2B55"/>
                 </a:solidFill>
               </a:rPr>
-              <a:t>Core Plate</a:t>
-            </a:r>
+              <a:t>Core Body</a:t>
+            </a:r>
+            <a:endParaRPr sz="1300" b="1" i="0" dirty="0">
+              <a:solidFill>
+                <a:srgbClr val="0D2B55"/>
+              </a:solidFill>
+            </a:endParaRPr>
           </a:p>
         </p:txBody>
       </p:sp>
@@ -7593,20 +7454,20 @@
       </p:sp>
       <p:sp>
         <p:nvSpPr>
-          <p:cNvPr id="18" name="Rectangle 17"/>
+          <p:cNvPr id="21" name="Rectangle 20"/>
           <p:cNvSpPr/>
           <p:nvPr/>
         </p:nvSpPr>
         <p:spPr>
           <a:xfrm>
-            <a:off x="960120" y="2651760"/>
-            <a:ext cx="5166360" cy="1024128"/>
-          </a:xfrm>
-          <a:prstGeom prst="rect">
-            <a:avLst/>
-          </a:prstGeom>
-          <a:solidFill>
-            <a:srgbClr val="FFFFFF"/>
+            <a:off x="365760" y="3840480"/>
+            <a:ext cx="548640" cy="1024128"/>
+          </a:xfrm>
+          <a:prstGeom prst="rect">
+            <a:avLst/>
+          </a:prstGeom>
+          <a:solidFill>
+            <a:srgbClr val="1A528C"/>
           </a:solidFill>
           <a:ln>
             <a:noFill/>
@@ -7637,14 +7498,48 @@
       </p:sp>
       <p:sp>
         <p:nvSpPr>
-          <p:cNvPr id="19" name="TextBox 18"/>
-          <p:cNvSpPr txBox="1"/>
-          <p:nvPr/>
-        </p:nvSpPr>
-        <p:spPr>
-          <a:xfrm>
-            <a:off x="1051560" y="2706624"/>
-            <a:ext cx="4983480" cy="347472"/>
+          <p:cNvPr id="22" name="TextBox 21"/>
+          <p:cNvSpPr txBox="1"/>
+          <p:nvPr/>
+        </p:nvSpPr>
+        <p:spPr>
+          <a:xfrm>
+            <a:off x="402336" y="4114800"/>
+            <a:ext cx="475488" cy="475488"/>
+          </a:xfrm>
+          <a:prstGeom prst="rect">
+            <a:avLst/>
+          </a:prstGeom>
+          <a:noFill/>
+        </p:spPr>
+        <p:txBody>
+          <a:bodyPr wrap="square">
+            <a:spAutoFit/>
+          </a:bodyPr>
+          <a:lstStyle/>
+          <a:p>
+            <a:pPr algn="ctr"/>
+            <a:r>
+              <a:rPr sz="2000" b="1" i="0">
+                <a:solidFill>
+                  <a:srgbClr val="FFFFFF"/>
+                </a:solidFill>
+              </a:rPr>
+              <a:t>3</a:t>
+            </a:r>
+          </a:p>
+        </p:txBody>
+      </p:sp>
+      <p:sp>
+        <p:nvSpPr>
+          <p:cNvPr id="24" name="TextBox 23"/>
+          <p:cNvSpPr txBox="1"/>
+          <p:nvPr/>
+        </p:nvSpPr>
+        <p:spPr>
+          <a:xfrm>
+            <a:off x="7040880" y="2706624"/>
+            <a:ext cx="4983480" cy="292388"/>
           </a:xfrm>
           <a:prstGeom prst="rect">
             <a:avLst/>
@@ -7659,25 +7554,25 @@
           <a:p>
             <a:pPr algn="l"/>
             <a:r>
-              <a:rPr sz="1300" b="1" i="0">
+              <a:rPr sz="1300" b="1" i="0" dirty="0">
                 <a:solidFill>
                   <a:srgbClr val="0D2B55"/>
                 </a:solidFill>
               </a:rPr>
-              <a:t>Head Servo Mount</a:t>
-            </a:r>
-          </a:p>
-        </p:txBody>
-      </p:sp>
-      <p:sp>
-        <p:nvSpPr>
-          <p:cNvPr id="20" name="TextBox 19"/>
-          <p:cNvSpPr txBox="1"/>
-          <p:nvPr/>
-        </p:nvSpPr>
-        <p:spPr>
-          <a:xfrm>
-            <a:off x="1051560" y="3072384"/>
+              <a:t>Hip </a:t>
+            </a:r>
+          </a:p>
+        </p:txBody>
+      </p:sp>
+      <p:sp>
+        <p:nvSpPr>
+          <p:cNvPr id="25" name="TextBox 24"/>
+          <p:cNvSpPr txBox="1"/>
+          <p:nvPr/>
+        </p:nvSpPr>
+        <p:spPr>
+          <a:xfrm>
+            <a:off x="7040880" y="3072384"/>
             <a:ext cx="4983480" cy="548640"/>
           </a:xfrm>
           <a:prstGeom prst="rect">
@@ -7698,27 +7593,61 @@
                   <a:srgbClr val="1A1A2E"/>
                 </a:solidFill>
               </a:rPr>
-              <a:t>Centred on Core Plate; controls head rotation via MG90S (CH8)</a:t>
-            </a:r>
-          </a:p>
-        </p:txBody>
-      </p:sp>
-      <p:sp>
-        <p:nvSpPr>
-          <p:cNvPr id="21" name="Rectangle 20"/>
+              <a:t>Four symmetric press-fit pockets at FL, FR, RL, RR corners</a:t>
+            </a:r>
+          </a:p>
+        </p:txBody>
+      </p:sp>
+      <p:sp>
+        <p:nvSpPr>
+          <p:cNvPr id="27" name="TextBox 26"/>
+          <p:cNvSpPr txBox="1"/>
+          <p:nvPr/>
+        </p:nvSpPr>
+        <p:spPr>
+          <a:xfrm>
+            <a:off x="402336" y="5303520"/>
+            <a:ext cx="475488" cy="475488"/>
+          </a:xfrm>
+          <a:prstGeom prst="rect">
+            <a:avLst/>
+          </a:prstGeom>
+          <a:noFill/>
+        </p:spPr>
+        <p:txBody>
+          <a:bodyPr wrap="square">
+            <a:spAutoFit/>
+          </a:bodyPr>
+          <a:lstStyle/>
+          <a:p>
+            <a:pPr algn="ctr"/>
+            <a:r>
+              <a:rPr sz="2000" b="1" i="0" dirty="0">
+                <a:solidFill>
+                  <a:srgbClr val="FFFFFF"/>
+                </a:solidFill>
+              </a:rPr>
+              <a:t>4</a:t>
+            </a:r>
+          </a:p>
+        </p:txBody>
+      </p:sp>
+      <p:sp>
+        <p:nvSpPr>
+          <p:cNvPr id="28" name="Rectangle 27"/>
           <p:cNvSpPr/>
           <p:nvPr/>
         </p:nvSpPr>
         <p:spPr>
           <a:xfrm>
-            <a:off x="365760" y="3840480"/>
-            <a:ext cx="548640" cy="1024128"/>
-          </a:xfrm>
-          <a:prstGeom prst="rect">
-            <a:avLst/>
-          </a:prstGeom>
-          <a:solidFill>
-            <a:srgbClr val="1A528C"/>
+            <a:off x="6963156" y="1463040"/>
+            <a:ext cx="5166360" cy="1024128"/>
+          </a:xfrm>
+          <a:prstGeom prst="rect">
+            <a:avLst/>
+          </a:prstGeom>
+          <a:solidFill>
+            <a:srgbClr val="FFFFFF"/>
           </a:solidFill>
           <a:ln>
             <a:noFill/>
@@ -7749,54 +7678,104 @@
       </p:sp>
       <p:sp>
         <p:nvSpPr>
-          <p:cNvPr id="22" name="TextBox 21"/>
-          <p:cNvSpPr txBox="1"/>
-          <p:nvPr/>
-        </p:nvSpPr>
-        <p:spPr>
-          <a:xfrm>
-            <a:off x="402336" y="4114800"/>
-            <a:ext cx="475488" cy="475488"/>
-          </a:xfrm>
-          <a:prstGeom prst="rect">
-            <a:avLst/>
-          </a:prstGeom>
-          <a:noFill/>
-        </p:spPr>
-        <p:txBody>
-          <a:bodyPr wrap="square">
-            <a:spAutoFit/>
-          </a:bodyPr>
-          <a:lstStyle/>
-          <a:p>
-            <a:pPr algn="ctr"/>
-            <a:r>
-              <a:rPr sz="2000" b="1" i="0">
-                <a:solidFill>
-                  <a:srgbClr val="FFFFFF"/>
-                </a:solidFill>
-              </a:rPr>
-              <a:t>3</a:t>
-            </a:r>
-          </a:p>
-        </p:txBody>
-      </p:sp>
-      <p:sp>
-        <p:nvSpPr>
-          <p:cNvPr id="23" name="Rectangle 22"/>
+          <p:cNvPr id="29" name="TextBox 28"/>
+          <p:cNvSpPr txBox="1"/>
+          <p:nvPr/>
+        </p:nvSpPr>
+        <p:spPr>
+          <a:xfrm>
+            <a:off x="7054596" y="1517904"/>
+            <a:ext cx="4983480" cy="347472"/>
+          </a:xfrm>
+          <a:prstGeom prst="rect">
+            <a:avLst/>
+          </a:prstGeom>
+          <a:noFill/>
+        </p:spPr>
+        <p:txBody>
+          <a:bodyPr wrap="square">
+            <a:spAutoFit/>
+          </a:bodyPr>
+          <a:lstStyle/>
+          <a:p>
+            <a:pPr algn="l"/>
+            <a:r>
+              <a:rPr sz="1300" b="1" i="0">
+                <a:solidFill>
+                  <a:srgbClr val="0D2B55"/>
+                </a:solidFill>
+              </a:rPr>
+              <a:t>Upper Leg</a:t>
+            </a:r>
+          </a:p>
+        </p:txBody>
+      </p:sp>
+      <p:sp>
+        <p:nvSpPr>
+          <p:cNvPr id="30" name="TextBox 29"/>
+          <p:cNvSpPr txBox="1"/>
+          <p:nvPr/>
+        </p:nvSpPr>
+        <p:spPr>
+          <a:xfrm>
+            <a:off x="7054596" y="1883664"/>
+            <a:ext cx="4983480" cy="261610"/>
+          </a:xfrm>
+          <a:prstGeom prst="rect">
+            <a:avLst/>
+          </a:prstGeom>
+          <a:noFill/>
+        </p:spPr>
+        <p:txBody>
+          <a:bodyPr wrap="square">
+            <a:spAutoFit/>
+          </a:bodyPr>
+          <a:lstStyle/>
+          <a:p>
+            <a:pPr algn="l"/>
+            <a:r>
+              <a:rPr sz="1100" b="0" i="0" dirty="0">
+                <a:solidFill>
+                  <a:srgbClr val="1A1A2E"/>
+                </a:solidFill>
+              </a:rPr>
+              <a:t>45 mm </a:t>
+            </a:r>
+            <a:r>
+              <a:rPr lang="en-US" sz="1100" b="0" i="0" dirty="0">
+                <a:solidFill>
+                  <a:srgbClr val="1A1A2E"/>
+                </a:solidFill>
+              </a:rPr>
+              <a:t>PLA</a:t>
+            </a:r>
+            <a:r>
+              <a:rPr sz="1100" b="0" i="0" dirty="0">
+                <a:solidFill>
+                  <a:srgbClr val="1A1A2E"/>
+                </a:solidFill>
+              </a:rPr>
+              <a:t> link with servo horn connection hole at proximal end</a:t>
+            </a:r>
+          </a:p>
+        </p:txBody>
+      </p:sp>
+      <p:sp>
+        <p:nvSpPr>
+          <p:cNvPr id="31" name="Rectangle 30"/>
           <p:cNvSpPr/>
           <p:nvPr/>
         </p:nvSpPr>
         <p:spPr>
           <a:xfrm>
-            <a:off x="960120" y="3840480"/>
-            <a:ext cx="5166360" cy="1024128"/>
-          </a:xfrm>
-          <a:prstGeom prst="rect">
-            <a:avLst/>
-          </a:prstGeom>
-          <a:solidFill>
-            <a:srgbClr val="E8F0FB"/>
+            <a:off x="6355080" y="1463040"/>
+            <a:ext cx="548640" cy="1024128"/>
+          </a:xfrm>
+          <a:prstGeom prst="rect">
+            <a:avLst/>
+          </a:prstGeom>
+          <a:solidFill>
+            <a:srgbClr val="1A528C"/>
           </a:solidFill>
           <a:ln>
             <a:noFill/>
@@ -7827,88 +7806,59 @@
       </p:sp>
       <p:sp>
         <p:nvSpPr>
-          <p:cNvPr id="24" name="TextBox 23"/>
-          <p:cNvSpPr txBox="1"/>
-          <p:nvPr/>
-        </p:nvSpPr>
-        <p:spPr>
-          <a:xfrm>
-            <a:off x="1051560" y="3895344"/>
-            <a:ext cx="4983480" cy="347472"/>
-          </a:xfrm>
-          <a:prstGeom prst="rect">
-            <a:avLst/>
-          </a:prstGeom>
-          <a:noFill/>
-        </p:spPr>
-        <p:txBody>
-          <a:bodyPr wrap="square">
-            <a:spAutoFit/>
-          </a:bodyPr>
-          <a:lstStyle/>
-          <a:p>
-            <a:pPr algn="l"/>
-            <a:r>
-              <a:rPr sz="1300" b="1" i="0">
-                <a:solidFill>
-                  <a:srgbClr val="0D2B55"/>
-                </a:solidFill>
-              </a:rPr>
-              <a:t>Hip Servo Mounts</a:t>
-            </a:r>
-          </a:p>
-        </p:txBody>
-      </p:sp>
-      <p:sp>
-        <p:nvSpPr>
-          <p:cNvPr id="25" name="TextBox 24"/>
-          <p:cNvSpPr txBox="1"/>
-          <p:nvPr/>
-        </p:nvSpPr>
-        <p:spPr>
-          <a:xfrm>
-            <a:off x="1051560" y="4261104"/>
-            <a:ext cx="4983480" cy="548640"/>
-          </a:xfrm>
-          <a:prstGeom prst="rect">
-            <a:avLst/>
-          </a:prstGeom>
-          <a:noFill/>
-        </p:spPr>
-        <p:txBody>
-          <a:bodyPr wrap="square">
-            <a:spAutoFit/>
-          </a:bodyPr>
-          <a:lstStyle/>
-          <a:p>
-            <a:pPr algn="l"/>
-            <a:r>
-              <a:rPr sz="1100" b="0" i="0">
-                <a:solidFill>
-                  <a:srgbClr val="1A1A2E"/>
-                </a:solidFill>
-              </a:rPr>
-              <a:t>Four symmetric press-fit pockets at FL, FR, RL, RR corners</a:t>
-            </a:r>
-          </a:p>
-        </p:txBody>
-      </p:sp>
-      <p:sp>
-        <p:nvSpPr>
-          <p:cNvPr id="26" name="Rectangle 25"/>
+          <p:cNvPr id="32" name="TextBox 31"/>
+          <p:cNvSpPr txBox="1"/>
+          <p:nvPr/>
+        </p:nvSpPr>
+        <p:spPr>
+          <a:xfrm>
+            <a:off x="6391656" y="1737360"/>
+            <a:ext cx="475488" cy="400110"/>
+          </a:xfrm>
+          <a:prstGeom prst="rect">
+            <a:avLst/>
+          </a:prstGeom>
+          <a:noFill/>
+        </p:spPr>
+        <p:txBody>
+          <a:bodyPr wrap="square">
+            <a:spAutoFit/>
+          </a:bodyPr>
+          <a:lstStyle/>
+          <a:p>
+            <a:pPr algn="ctr"/>
+            <a:r>
+              <a:rPr lang="en-US" sz="2000" b="1" dirty="0">
+                <a:solidFill>
+                  <a:srgbClr val="FFFFFF"/>
+                </a:solidFill>
+              </a:rPr>
+              <a:t>4</a:t>
+            </a:r>
+            <a:endParaRPr sz="2000" b="1" i="0" dirty="0">
+              <a:solidFill>
+                <a:srgbClr val="FFFFFF"/>
+              </a:solidFill>
+            </a:endParaRPr>
+          </a:p>
+        </p:txBody>
+      </p:sp>
+      <p:sp>
+        <p:nvSpPr>
+          <p:cNvPr id="33" name="Rectangle 32"/>
           <p:cNvSpPr/>
           <p:nvPr/>
         </p:nvSpPr>
         <p:spPr>
           <a:xfrm>
-            <a:off x="365760" y="5029200"/>
-            <a:ext cx="548640" cy="1024128"/>
-          </a:xfrm>
-          <a:prstGeom prst="rect">
-            <a:avLst/>
-          </a:prstGeom>
-          <a:solidFill>
-            <a:srgbClr val="1A528C"/>
+            <a:off x="6963156" y="2651760"/>
+            <a:ext cx="5166360" cy="1024128"/>
+          </a:xfrm>
+          <a:prstGeom prst="rect">
+            <a:avLst/>
+          </a:prstGeom>
+          <a:solidFill>
+            <a:srgbClr val="E8F0FB"/>
           </a:solidFill>
           <a:ln>
             <a:noFill/>
@@ -7939,54 +7889,104 @@
       </p:sp>
       <p:sp>
         <p:nvSpPr>
-          <p:cNvPr id="27" name="TextBox 26"/>
-          <p:cNvSpPr txBox="1"/>
-          <p:nvPr/>
-        </p:nvSpPr>
-        <p:spPr>
-          <a:xfrm>
-            <a:off x="402336" y="5303520"/>
-            <a:ext cx="475488" cy="475488"/>
-          </a:xfrm>
-          <a:prstGeom prst="rect">
-            <a:avLst/>
-          </a:prstGeom>
-          <a:noFill/>
-        </p:spPr>
-        <p:txBody>
-          <a:bodyPr wrap="square">
-            <a:spAutoFit/>
-          </a:bodyPr>
-          <a:lstStyle/>
-          <a:p>
-            <a:pPr algn="ctr"/>
-            <a:r>
-              <a:rPr sz="2000" b="1" i="0">
-                <a:solidFill>
-                  <a:srgbClr val="FFFFFF"/>
-                </a:solidFill>
-              </a:rPr>
-              <a:t>4</a:t>
-            </a:r>
-          </a:p>
-        </p:txBody>
-      </p:sp>
-      <p:sp>
-        <p:nvSpPr>
-          <p:cNvPr id="28" name="Rectangle 27"/>
+          <p:cNvPr id="34" name="TextBox 33"/>
+          <p:cNvSpPr txBox="1"/>
+          <p:nvPr/>
+        </p:nvSpPr>
+        <p:spPr>
+          <a:xfrm>
+            <a:off x="7040880" y="2706624"/>
+            <a:ext cx="4983480" cy="347472"/>
+          </a:xfrm>
+          <a:prstGeom prst="rect">
+            <a:avLst/>
+          </a:prstGeom>
+          <a:noFill/>
+        </p:spPr>
+        <p:txBody>
+          <a:bodyPr wrap="square">
+            <a:spAutoFit/>
+          </a:bodyPr>
+          <a:lstStyle/>
+          <a:p>
+            <a:pPr algn="l"/>
+            <a:r>
+              <a:rPr sz="1300" b="1" i="0">
+                <a:solidFill>
+                  <a:srgbClr val="0D2B55"/>
+                </a:solidFill>
+              </a:rPr>
+              <a:t>Lower Leg</a:t>
+            </a:r>
+          </a:p>
+        </p:txBody>
+      </p:sp>
+      <p:sp>
+        <p:nvSpPr>
+          <p:cNvPr id="35" name="TextBox 34"/>
+          <p:cNvSpPr txBox="1"/>
+          <p:nvPr/>
+        </p:nvSpPr>
+        <p:spPr>
+          <a:xfrm>
+            <a:off x="7040880" y="3072384"/>
+            <a:ext cx="4983480" cy="261610"/>
+          </a:xfrm>
+          <a:prstGeom prst="rect">
+            <a:avLst/>
+          </a:prstGeom>
+          <a:noFill/>
+        </p:spPr>
+        <p:txBody>
+          <a:bodyPr wrap="square">
+            <a:spAutoFit/>
+          </a:bodyPr>
+          <a:lstStyle/>
+          <a:p>
+            <a:pPr algn="l"/>
+            <a:r>
+              <a:rPr sz="1100" b="0" i="0" dirty="0">
+                <a:solidFill>
+                  <a:srgbClr val="1A1A2E"/>
+                </a:solidFill>
+              </a:rPr>
+              <a:t>55 mm </a:t>
+            </a:r>
+            <a:r>
+              <a:rPr lang="en-US" sz="1100" b="0" i="0" dirty="0">
+                <a:solidFill>
+                  <a:srgbClr val="1A1A2E"/>
+                </a:solidFill>
+              </a:rPr>
+              <a:t>PLA</a:t>
+            </a:r>
+            <a:r>
+              <a:rPr sz="1100" b="0" i="0" dirty="0">
+                <a:solidFill>
+                  <a:srgbClr val="1A1A2E"/>
+                </a:solidFill>
+              </a:rPr>
+              <a:t> link with foot pad boss at distal (terminal) end</a:t>
+            </a:r>
+          </a:p>
+        </p:txBody>
+      </p:sp>
+      <p:sp>
+        <p:nvSpPr>
+          <p:cNvPr id="36" name="Rectangle 35"/>
           <p:cNvSpPr/>
           <p:nvPr/>
         </p:nvSpPr>
         <p:spPr>
           <a:xfrm>
-            <a:off x="960120" y="5029200"/>
-            <a:ext cx="5166360" cy="1024128"/>
-          </a:xfrm>
-          <a:prstGeom prst="rect">
-            <a:avLst/>
-          </a:prstGeom>
-          <a:solidFill>
-            <a:srgbClr val="FFFFFF"/>
+            <a:off x="6355080" y="2651760"/>
+            <a:ext cx="548640" cy="1024128"/>
+          </a:xfrm>
+          <a:prstGeom prst="rect">
+            <a:avLst/>
+          </a:prstGeom>
+          <a:solidFill>
+            <a:srgbClr val="1A528C"/>
           </a:solidFill>
           <a:ln>
             <a:noFill/>
@@ -8017,104 +8017,59 @@
       </p:sp>
       <p:sp>
         <p:nvSpPr>
-          <p:cNvPr id="29" name="TextBox 28"/>
-          <p:cNvSpPr txBox="1"/>
-          <p:nvPr/>
-        </p:nvSpPr>
-        <p:spPr>
-          <a:xfrm>
-            <a:off x="1051560" y="5084064"/>
-            <a:ext cx="4983480" cy="347472"/>
-          </a:xfrm>
-          <a:prstGeom prst="rect">
-            <a:avLst/>
-          </a:prstGeom>
-          <a:noFill/>
-        </p:spPr>
-        <p:txBody>
-          <a:bodyPr wrap="square">
-            <a:spAutoFit/>
-          </a:bodyPr>
-          <a:lstStyle/>
-          <a:p>
-            <a:pPr algn="l"/>
-            <a:r>
-              <a:rPr sz="1300" b="1" i="0">
-                <a:solidFill>
-                  <a:srgbClr val="0D2B55"/>
-                </a:solidFill>
-              </a:rPr>
-              <a:t>Upper Leg</a:t>
-            </a:r>
-          </a:p>
-        </p:txBody>
-      </p:sp>
-      <p:sp>
-        <p:nvSpPr>
-          <p:cNvPr id="30" name="TextBox 29"/>
-          <p:cNvSpPr txBox="1"/>
-          <p:nvPr/>
-        </p:nvSpPr>
-        <p:spPr>
-          <a:xfrm>
-            <a:off x="1051560" y="5449824"/>
-            <a:ext cx="4983480" cy="261610"/>
-          </a:xfrm>
-          <a:prstGeom prst="rect">
-            <a:avLst/>
-          </a:prstGeom>
-          <a:noFill/>
-        </p:spPr>
-        <p:txBody>
-          <a:bodyPr wrap="square">
-            <a:spAutoFit/>
-          </a:bodyPr>
-          <a:lstStyle/>
-          <a:p>
-            <a:pPr algn="l"/>
-            <a:r>
-              <a:rPr sz="1100" b="0" i="0" dirty="0">
-                <a:solidFill>
-                  <a:srgbClr val="1A1A2E"/>
-                </a:solidFill>
-              </a:rPr>
-              <a:t>45 mm </a:t>
-            </a:r>
-            <a:r>
-              <a:rPr lang="en-US" sz="1100" b="0" i="0" dirty="0">
-                <a:solidFill>
-                  <a:srgbClr val="1A1A2E"/>
-                </a:solidFill>
-              </a:rPr>
-              <a:t>PLA</a:t>
-            </a:r>
-            <a:r>
-              <a:rPr sz="1100" b="0" i="0" dirty="0">
-                <a:solidFill>
-                  <a:srgbClr val="1A1A2E"/>
-                </a:solidFill>
-              </a:rPr>
-              <a:t> link with servo horn connection hole at proximal end</a:t>
-            </a:r>
-          </a:p>
-        </p:txBody>
-      </p:sp>
-      <p:sp>
-        <p:nvSpPr>
-          <p:cNvPr id="31" name="Rectangle 30"/>
+          <p:cNvPr id="37" name="TextBox 36"/>
+          <p:cNvSpPr txBox="1"/>
+          <p:nvPr/>
+        </p:nvSpPr>
+        <p:spPr>
+          <a:xfrm>
+            <a:off x="6391656" y="2926080"/>
+            <a:ext cx="475488" cy="400110"/>
+          </a:xfrm>
+          <a:prstGeom prst="rect">
+            <a:avLst/>
+          </a:prstGeom>
+          <a:noFill/>
+        </p:spPr>
+        <p:txBody>
+          <a:bodyPr wrap="square">
+            <a:spAutoFit/>
+          </a:bodyPr>
+          <a:lstStyle/>
+          <a:p>
+            <a:pPr algn="ctr"/>
+            <a:r>
+              <a:rPr lang="en-US" sz="2000" b="1" dirty="0">
+                <a:solidFill>
+                  <a:srgbClr val="FFFFFF"/>
+                </a:solidFill>
+              </a:rPr>
+              <a:t>5</a:t>
+            </a:r>
+            <a:endParaRPr sz="2000" b="1" i="0" dirty="0">
+              <a:solidFill>
+                <a:srgbClr val="FFFFFF"/>
+              </a:solidFill>
+            </a:endParaRPr>
+          </a:p>
+        </p:txBody>
+      </p:sp>
+      <p:sp>
+        <p:nvSpPr>
+          <p:cNvPr id="38" name="Rectangle 37"/>
           <p:cNvSpPr/>
           <p:nvPr/>
         </p:nvSpPr>
         <p:spPr>
           <a:xfrm>
-            <a:off x="6355080" y="1463040"/>
-            <a:ext cx="548640" cy="1024128"/>
-          </a:xfrm>
-          <a:prstGeom prst="rect">
-            <a:avLst/>
-          </a:prstGeom>
-          <a:solidFill>
-            <a:srgbClr val="1A528C"/>
+            <a:off x="973836" y="2651760"/>
+            <a:ext cx="5166360" cy="1024128"/>
+          </a:xfrm>
+          <a:prstGeom prst="rect">
+            <a:avLst/>
+          </a:prstGeom>
+          <a:solidFill>
+            <a:srgbClr val="FFFFFF"/>
           </a:solidFill>
           <a:ln>
             <a:noFill/>
@@ -8145,54 +8100,88 @@
       </p:sp>
       <p:sp>
         <p:nvSpPr>
-          <p:cNvPr id="32" name="TextBox 31"/>
-          <p:cNvSpPr txBox="1"/>
-          <p:nvPr/>
-        </p:nvSpPr>
-        <p:spPr>
-          <a:xfrm>
-            <a:off x="6391656" y="1737360"/>
-            <a:ext cx="475488" cy="475488"/>
-          </a:xfrm>
-          <a:prstGeom prst="rect">
-            <a:avLst/>
-          </a:prstGeom>
-          <a:noFill/>
-        </p:spPr>
-        <p:txBody>
-          <a:bodyPr wrap="square">
-            <a:spAutoFit/>
-          </a:bodyPr>
-          <a:lstStyle/>
-          <a:p>
-            <a:pPr algn="ctr"/>
-            <a:r>
-              <a:rPr sz="2000" b="1" i="0">
-                <a:solidFill>
-                  <a:srgbClr val="FFFFFF"/>
-                </a:solidFill>
-              </a:rPr>
-              <a:t>5</a:t>
-            </a:r>
-          </a:p>
-        </p:txBody>
-      </p:sp>
-      <p:sp>
-        <p:nvSpPr>
-          <p:cNvPr id="33" name="Rectangle 32"/>
+          <p:cNvPr id="39" name="TextBox 38"/>
+          <p:cNvSpPr txBox="1"/>
+          <p:nvPr/>
+        </p:nvSpPr>
+        <p:spPr>
+          <a:xfrm>
+            <a:off x="1065276" y="2706624"/>
+            <a:ext cx="4983480" cy="347472"/>
+          </a:xfrm>
+          <a:prstGeom prst="rect">
+            <a:avLst/>
+          </a:prstGeom>
+          <a:noFill/>
+        </p:spPr>
+        <p:txBody>
+          <a:bodyPr wrap="square">
+            <a:spAutoFit/>
+          </a:bodyPr>
+          <a:lstStyle/>
+          <a:p>
+            <a:pPr algn="l"/>
+            <a:r>
+              <a:rPr sz="1300" b="1" i="0">
+                <a:solidFill>
+                  <a:srgbClr val="0D2B55"/>
+                </a:solidFill>
+              </a:rPr>
+              <a:t>Head Box</a:t>
+            </a:r>
+          </a:p>
+        </p:txBody>
+      </p:sp>
+      <p:sp>
+        <p:nvSpPr>
+          <p:cNvPr id="40" name="TextBox 39"/>
+          <p:cNvSpPr txBox="1"/>
+          <p:nvPr/>
+        </p:nvSpPr>
+        <p:spPr>
+          <a:xfrm>
+            <a:off x="1065276" y="3072384"/>
+            <a:ext cx="4983480" cy="548640"/>
+          </a:xfrm>
+          <a:prstGeom prst="rect">
+            <a:avLst/>
+          </a:prstGeom>
+          <a:noFill/>
+        </p:spPr>
+        <p:txBody>
+          <a:bodyPr wrap="square">
+            <a:spAutoFit/>
+          </a:bodyPr>
+          <a:lstStyle/>
+          <a:p>
+            <a:pPr algn="l"/>
+            <a:r>
+              <a:rPr sz="1100" b="0" i="0">
+                <a:solidFill>
+                  <a:srgbClr val="1A1A2E"/>
+                </a:solidFill>
+              </a:rPr>
+              <a:t>Enclosure designed around ESP32 and PCA9685 PCB footprints (85×65×45 mm)</a:t>
+            </a:r>
+          </a:p>
+        </p:txBody>
+      </p:sp>
+      <p:sp>
+        <p:nvSpPr>
+          <p:cNvPr id="41" name="Rectangle 40"/>
           <p:cNvSpPr/>
           <p:nvPr/>
         </p:nvSpPr>
         <p:spPr>
           <a:xfrm>
-            <a:off x="6949440" y="1463040"/>
-            <a:ext cx="5166360" cy="1024128"/>
-          </a:xfrm>
-          <a:prstGeom prst="rect">
-            <a:avLst/>
-          </a:prstGeom>
-          <a:solidFill>
-            <a:srgbClr val="E8F0FB"/>
+            <a:off x="6355080" y="3840480"/>
+            <a:ext cx="548640" cy="1024128"/>
+          </a:xfrm>
+          <a:prstGeom prst="rect">
+            <a:avLst/>
+          </a:prstGeom>
+          <a:solidFill>
+            <a:srgbClr val="1A528C"/>
           </a:solidFill>
           <a:ln>
             <a:noFill/>
@@ -8223,104 +8212,59 @@
       </p:sp>
       <p:sp>
         <p:nvSpPr>
-          <p:cNvPr id="34" name="TextBox 33"/>
-          <p:cNvSpPr txBox="1"/>
-          <p:nvPr/>
-        </p:nvSpPr>
-        <p:spPr>
-          <a:xfrm>
-            <a:off x="7040880" y="1517904"/>
-            <a:ext cx="4983480" cy="347472"/>
-          </a:xfrm>
-          <a:prstGeom prst="rect">
-            <a:avLst/>
-          </a:prstGeom>
-          <a:noFill/>
-        </p:spPr>
-        <p:txBody>
-          <a:bodyPr wrap="square">
-            <a:spAutoFit/>
-          </a:bodyPr>
-          <a:lstStyle/>
-          <a:p>
-            <a:pPr algn="l"/>
-            <a:r>
-              <a:rPr sz="1300" b="1" i="0">
-                <a:solidFill>
-                  <a:srgbClr val="0D2B55"/>
-                </a:solidFill>
-              </a:rPr>
-              <a:t>Lower Leg</a:t>
-            </a:r>
-          </a:p>
-        </p:txBody>
-      </p:sp>
-      <p:sp>
-        <p:nvSpPr>
-          <p:cNvPr id="35" name="TextBox 34"/>
-          <p:cNvSpPr txBox="1"/>
-          <p:nvPr/>
-        </p:nvSpPr>
-        <p:spPr>
-          <a:xfrm>
-            <a:off x="7040880" y="1883664"/>
-            <a:ext cx="4983480" cy="261610"/>
-          </a:xfrm>
-          <a:prstGeom prst="rect">
-            <a:avLst/>
-          </a:prstGeom>
-          <a:noFill/>
-        </p:spPr>
-        <p:txBody>
-          <a:bodyPr wrap="square">
-            <a:spAutoFit/>
-          </a:bodyPr>
-          <a:lstStyle/>
-          <a:p>
-            <a:pPr algn="l"/>
-            <a:r>
-              <a:rPr sz="1100" b="0" i="0" dirty="0">
-                <a:solidFill>
-                  <a:srgbClr val="1A1A2E"/>
-                </a:solidFill>
-              </a:rPr>
-              <a:t>55 mm </a:t>
-            </a:r>
-            <a:r>
-              <a:rPr lang="en-US" sz="1100" b="0" i="0" dirty="0">
-                <a:solidFill>
-                  <a:srgbClr val="1A1A2E"/>
-                </a:solidFill>
-              </a:rPr>
-              <a:t>PLA</a:t>
-            </a:r>
-            <a:r>
-              <a:rPr sz="1100" b="0" i="0" dirty="0">
-                <a:solidFill>
-                  <a:srgbClr val="1A1A2E"/>
-                </a:solidFill>
-              </a:rPr>
-              <a:t> link with foot pad boss at distal (terminal) end</a:t>
-            </a:r>
-          </a:p>
-        </p:txBody>
-      </p:sp>
-      <p:sp>
-        <p:nvSpPr>
-          <p:cNvPr id="36" name="Rectangle 35"/>
+          <p:cNvPr id="42" name="TextBox 41"/>
+          <p:cNvSpPr txBox="1"/>
+          <p:nvPr/>
+        </p:nvSpPr>
+        <p:spPr>
+          <a:xfrm>
+            <a:off x="6391656" y="4114800"/>
+            <a:ext cx="475488" cy="400110"/>
+          </a:xfrm>
+          <a:prstGeom prst="rect">
+            <a:avLst/>
+          </a:prstGeom>
+          <a:noFill/>
+        </p:spPr>
+        <p:txBody>
+          <a:bodyPr wrap="square">
+            <a:spAutoFit/>
+          </a:bodyPr>
+          <a:lstStyle/>
+          <a:p>
+            <a:pPr algn="ctr"/>
+            <a:r>
+              <a:rPr lang="en-US" sz="2000" b="1" i="0" dirty="0">
+                <a:solidFill>
+                  <a:srgbClr val="FFFFFF"/>
+                </a:solidFill>
+              </a:rPr>
+              <a:t>6</a:t>
+            </a:r>
+            <a:endParaRPr sz="2000" b="1" i="0" dirty="0">
+              <a:solidFill>
+                <a:srgbClr val="FFFFFF"/>
+              </a:solidFill>
+            </a:endParaRPr>
+          </a:p>
+        </p:txBody>
+      </p:sp>
+      <p:sp>
+        <p:nvSpPr>
+          <p:cNvPr id="43" name="Rectangle 42"/>
           <p:cNvSpPr/>
           <p:nvPr/>
         </p:nvSpPr>
         <p:spPr>
           <a:xfrm>
-            <a:off x="6355080" y="2651760"/>
-            <a:ext cx="548640" cy="1024128"/>
-          </a:xfrm>
-          <a:prstGeom prst="rect">
-            <a:avLst/>
-          </a:prstGeom>
-          <a:solidFill>
-            <a:srgbClr val="1A528C"/>
+            <a:off x="6963156" y="3843559"/>
+            <a:ext cx="5166360" cy="1024128"/>
+          </a:xfrm>
+          <a:prstGeom prst="rect">
+            <a:avLst/>
+          </a:prstGeom>
+          <a:solidFill>
+            <a:srgbClr val="E8F0FB"/>
           </a:solidFill>
           <a:ln>
             <a:noFill/>
@@ -8351,54 +8295,94 @@
       </p:sp>
       <p:sp>
         <p:nvSpPr>
-          <p:cNvPr id="37" name="TextBox 36"/>
-          <p:cNvSpPr txBox="1"/>
-          <p:nvPr/>
-        </p:nvSpPr>
-        <p:spPr>
-          <a:xfrm>
-            <a:off x="6391656" y="2926080"/>
-            <a:ext cx="475488" cy="475488"/>
-          </a:xfrm>
-          <a:prstGeom prst="rect">
-            <a:avLst/>
-          </a:prstGeom>
-          <a:noFill/>
-        </p:spPr>
-        <p:txBody>
-          <a:bodyPr wrap="square">
-            <a:spAutoFit/>
-          </a:bodyPr>
-          <a:lstStyle/>
-          <a:p>
-            <a:pPr algn="ctr"/>
-            <a:r>
-              <a:rPr sz="2000" b="1" i="0">
-                <a:solidFill>
-                  <a:srgbClr val="FFFFFF"/>
-                </a:solidFill>
-              </a:rPr>
-              <a:t>6</a:t>
-            </a:r>
-          </a:p>
-        </p:txBody>
-      </p:sp>
-      <p:sp>
-        <p:nvSpPr>
-          <p:cNvPr id="38" name="Rectangle 37"/>
+          <p:cNvPr id="44" name="TextBox 43"/>
+          <p:cNvSpPr txBox="1"/>
+          <p:nvPr/>
+        </p:nvSpPr>
+        <p:spPr>
+          <a:xfrm>
+            <a:off x="7054596" y="3898423"/>
+            <a:ext cx="4983480" cy="347472"/>
+          </a:xfrm>
+          <a:prstGeom prst="rect">
+            <a:avLst/>
+          </a:prstGeom>
+          <a:noFill/>
+        </p:spPr>
+        <p:txBody>
+          <a:bodyPr wrap="square">
+            <a:spAutoFit/>
+          </a:bodyPr>
+          <a:lstStyle/>
+          <a:p>
+            <a:pPr algn="l"/>
+            <a:r>
+              <a:rPr sz="1300" b="1" i="0">
+                <a:solidFill>
+                  <a:srgbClr val="0D2B55"/>
+                </a:solidFill>
+              </a:rPr>
+              <a:t>Assembly</a:t>
+            </a:r>
+          </a:p>
+        </p:txBody>
+      </p:sp>
+      <p:sp>
+        <p:nvSpPr>
+          <p:cNvPr id="45" name="TextBox 44"/>
+          <p:cNvSpPr txBox="1"/>
+          <p:nvPr/>
+        </p:nvSpPr>
+        <p:spPr>
+          <a:xfrm>
+            <a:off x="7054596" y="4264183"/>
+            <a:ext cx="4983480" cy="548640"/>
+          </a:xfrm>
+          <a:prstGeom prst="rect">
+            <a:avLst/>
+          </a:prstGeom>
+          <a:noFill/>
+        </p:spPr>
+        <p:txBody>
+          <a:bodyPr wrap="square">
+            <a:spAutoFit/>
+          </a:bodyPr>
+          <a:lstStyle/>
+          <a:p>
+            <a:pPr algn="l"/>
+            <a:r>
+              <a:rPr sz="1100" b="0" i="0" dirty="0">
+                <a:solidFill>
+                  <a:srgbClr val="1A1A2E"/>
+                </a:solidFill>
+              </a:rPr>
+              <a:t>All bodies assembled in FreeCAD Assembly with correct spacing and constraints</a:t>
+            </a:r>
+          </a:p>
+        </p:txBody>
+      </p:sp>
+      <p:sp>
+        <p:nvSpPr>
+          <p:cNvPr id="18" name="Rectangle 17">
+            <a:extLst>
+              <a:ext uri="{FF2B5EF4-FFF2-40B4-BE49-F238E27FC236}">
+                <a16:creationId xmlns:a16="http://schemas.microsoft.com/office/drawing/2014/main" id="{CDE26688-CA75-F182-A89E-C3D562818D48}"/>
+              </a:ext>
+            </a:extLst>
+          </p:cNvPr>
           <p:cNvSpPr/>
           <p:nvPr/>
         </p:nvSpPr>
         <p:spPr>
           <a:xfrm>
-            <a:off x="6949440" y="2651760"/>
+            <a:off x="973836" y="3843559"/>
             <a:ext cx="5166360" cy="1024128"/>
           </a:xfrm>
           <a:prstGeom prst="rect">
             <a:avLst/>
           </a:prstGeom>
           <a:solidFill>
-            <a:srgbClr val="FFFFFF"/>
+            <a:srgbClr val="E8F0FB"/>
           </a:solidFill>
           <a:ln>
             <a:noFill/>
@@ -8429,13 +8413,19 @@
       </p:sp>
       <p:sp>
         <p:nvSpPr>
-          <p:cNvPr id="39" name="TextBox 38"/>
-          <p:cNvSpPr txBox="1"/>
-          <p:nvPr/>
-        </p:nvSpPr>
-        <p:spPr>
-          <a:xfrm>
-            <a:off x="7040880" y="2706624"/>
+          <p:cNvPr id="19" name="TextBox 18">
+            <a:extLst>
+              <a:ext uri="{FF2B5EF4-FFF2-40B4-BE49-F238E27FC236}">
+                <a16:creationId xmlns:a16="http://schemas.microsoft.com/office/drawing/2014/main" id="{6BD2871F-E663-DB42-B488-3945D2DFDDA5}"/>
+              </a:ext>
+            </a:extLst>
+          </p:cNvPr>
+          <p:cNvSpPr txBox="1"/>
+          <p:nvPr/>
+        </p:nvSpPr>
+        <p:spPr>
+          <a:xfrm>
+            <a:off x="1065276" y="3898423"/>
             <a:ext cx="4983480" cy="347472"/>
           </a:xfrm>
           <a:prstGeom prst="rect">
@@ -8451,25 +8441,31 @@
           <a:p>
             <a:pPr algn="l"/>
             <a:r>
-              <a:rPr sz="1300" b="1" i="0">
+              <a:rPr sz="1300" b="1" i="0" dirty="0">
                 <a:solidFill>
                   <a:srgbClr val="0D2B55"/>
                 </a:solidFill>
               </a:rPr>
-              <a:t>Head Box</a:t>
-            </a:r>
-          </a:p>
-        </p:txBody>
-      </p:sp>
-      <p:sp>
-        <p:nvSpPr>
-          <p:cNvPr id="40" name="TextBox 39"/>
-          <p:cNvSpPr txBox="1"/>
-          <p:nvPr/>
-        </p:nvSpPr>
-        <p:spPr>
-          <a:xfrm>
-            <a:off x="7040880" y="3072384"/>
+              <a:t>Hip Servo Mounts</a:t>
+            </a:r>
+          </a:p>
+        </p:txBody>
+      </p:sp>
+      <p:sp>
+        <p:nvSpPr>
+          <p:cNvPr id="20" name="TextBox 19">
+            <a:extLst>
+              <a:ext uri="{FF2B5EF4-FFF2-40B4-BE49-F238E27FC236}">
+                <a16:creationId xmlns:a16="http://schemas.microsoft.com/office/drawing/2014/main" id="{A69E85CD-D0B5-9586-4113-FF633F70800F}"/>
+              </a:ext>
+            </a:extLst>
+          </p:cNvPr>
+          <p:cNvSpPr txBox="1"/>
+          <p:nvPr/>
+        </p:nvSpPr>
+        <p:spPr>
+          <a:xfrm>
+            <a:off x="1065276" y="4264183"/>
             <a:ext cx="4983480" cy="548640"/>
           </a:xfrm>
           <a:prstGeom prst="rect">
@@ -8485,202 +8481,12 @@
           <a:p>
             <a:pPr algn="l"/>
             <a:r>
-              <a:rPr sz="1100" b="0" i="0">
+              <a:rPr sz="1100" b="0" i="0" dirty="0">
                 <a:solidFill>
                   <a:srgbClr val="1A1A2E"/>
                 </a:solidFill>
               </a:rPr>
-              <a:t>Enclosure designed around ESP32 and PCA9685 PCB footprints (85×65×45 mm)</a:t>
-            </a:r>
-          </a:p>
-        </p:txBody>
-      </p:sp>
-      <p:sp>
-        <p:nvSpPr>
-          <p:cNvPr id="41" name="Rectangle 40"/>
-          <p:cNvSpPr/>
-          <p:nvPr/>
-        </p:nvSpPr>
-        <p:spPr>
-          <a:xfrm>
-            <a:off x="6355080" y="3840480"/>
-            <a:ext cx="548640" cy="1024128"/>
-          </a:xfrm>
-          <a:prstGeom prst="rect">
-            <a:avLst/>
-          </a:prstGeom>
-          <a:solidFill>
-            <a:srgbClr val="1A528C"/>
-          </a:solidFill>
-          <a:ln>
-            <a:noFill/>
-          </a:ln>
-        </p:spPr>
-        <p:style>
-          <a:lnRef idx="1">
-            <a:schemeClr val="accent1"/>
-          </a:lnRef>
-          <a:fillRef idx="3">
-            <a:schemeClr val="accent1"/>
-          </a:fillRef>
-          <a:effectRef idx="2">
-            <a:schemeClr val="accent1"/>
-          </a:effectRef>
-          <a:fontRef idx="minor">
-            <a:schemeClr val="lt1"/>
-          </a:fontRef>
-        </p:style>
-        <p:txBody>
-          <a:bodyPr rtlCol="0" anchor="ctr"/>
-          <a:lstStyle/>
-          <a:p>
-            <a:pPr algn="ctr"/>
-            <a:endParaRPr/>
-          </a:p>
-        </p:txBody>
-      </p:sp>
-      <p:sp>
-        <p:nvSpPr>
-          <p:cNvPr id="42" name="TextBox 41"/>
-          <p:cNvSpPr txBox="1"/>
-          <p:nvPr/>
-        </p:nvSpPr>
-        <p:spPr>
-          <a:xfrm>
-            <a:off x="6391656" y="4114800"/>
-            <a:ext cx="475488" cy="475488"/>
-          </a:xfrm>
-          <a:prstGeom prst="rect">
-            <a:avLst/>
-          </a:prstGeom>
-          <a:noFill/>
-        </p:spPr>
-        <p:txBody>
-          <a:bodyPr wrap="square">
-            <a:spAutoFit/>
-          </a:bodyPr>
-          <a:lstStyle/>
-          <a:p>
-            <a:pPr algn="ctr"/>
-            <a:r>
-              <a:rPr sz="2000" b="1" i="0">
-                <a:solidFill>
-                  <a:srgbClr val="FFFFFF"/>
-                </a:solidFill>
-              </a:rPr>
-              <a:t>7</a:t>
-            </a:r>
-          </a:p>
-        </p:txBody>
-      </p:sp>
-      <p:sp>
-        <p:nvSpPr>
-          <p:cNvPr id="43" name="Rectangle 42"/>
-          <p:cNvSpPr/>
-          <p:nvPr/>
-        </p:nvSpPr>
-        <p:spPr>
-          <a:xfrm>
-            <a:off x="6949440" y="3840480"/>
-            <a:ext cx="5166360" cy="1024128"/>
-          </a:xfrm>
-          <a:prstGeom prst="rect">
-            <a:avLst/>
-          </a:prstGeom>
-          <a:solidFill>
-            <a:srgbClr val="E8F0FB"/>
-          </a:solidFill>
-          <a:ln>
-            <a:noFill/>
-          </a:ln>
-        </p:spPr>
-        <p:style>
-          <a:lnRef idx="1">
-            <a:schemeClr val="accent1"/>
-          </a:lnRef>
-          <a:fillRef idx="3">
-            <a:schemeClr val="accent1"/>
-          </a:fillRef>
-          <a:effectRef idx="2">
-            <a:schemeClr val="accent1"/>
-          </a:effectRef>
-          <a:fontRef idx="minor">
-            <a:schemeClr val="lt1"/>
-          </a:fontRef>
-        </p:style>
-        <p:txBody>
-          <a:bodyPr rtlCol="0" anchor="ctr"/>
-          <a:lstStyle/>
-          <a:p>
-            <a:pPr algn="ctr"/>
-            <a:endParaRPr/>
-          </a:p>
-        </p:txBody>
-      </p:sp>
-      <p:sp>
-        <p:nvSpPr>
-          <p:cNvPr id="44" name="TextBox 43"/>
-          <p:cNvSpPr txBox="1"/>
-          <p:nvPr/>
-        </p:nvSpPr>
-        <p:spPr>
-          <a:xfrm>
-            <a:off x="7040880" y="3895344"/>
-            <a:ext cx="4983480" cy="347472"/>
-          </a:xfrm>
-          <a:prstGeom prst="rect">
-            <a:avLst/>
-          </a:prstGeom>
-          <a:noFill/>
-        </p:spPr>
-        <p:txBody>
-          <a:bodyPr wrap="square">
-            <a:spAutoFit/>
-          </a:bodyPr>
-          <a:lstStyle/>
-          <a:p>
-            <a:pPr algn="l"/>
-            <a:r>
-              <a:rPr sz="1300" b="1" i="0">
-                <a:solidFill>
-                  <a:srgbClr val="0D2B55"/>
-                </a:solidFill>
-              </a:rPr>
-              <a:t>Assembly</a:t>
-            </a:r>
-          </a:p>
-        </p:txBody>
-      </p:sp>
-      <p:sp>
-        <p:nvSpPr>
-          <p:cNvPr id="45" name="TextBox 44"/>
-          <p:cNvSpPr txBox="1"/>
-          <p:nvPr/>
-        </p:nvSpPr>
-        <p:spPr>
-          <a:xfrm>
-            <a:off x="7040880" y="4261104"/>
-            <a:ext cx="4983480" cy="548640"/>
-          </a:xfrm>
-          <a:prstGeom prst="rect">
-            <a:avLst/>
-          </a:prstGeom>
-          <a:noFill/>
-        </p:spPr>
-        <p:txBody>
-          <a:bodyPr wrap="square">
-            <a:spAutoFit/>
-          </a:bodyPr>
-          <a:lstStyle/>
-          <a:p>
-            <a:pPr algn="l"/>
-            <a:r>
-              <a:rPr sz="1100" b="0" i="0">
-                <a:solidFill>
-                  <a:srgbClr val="1A1A2E"/>
-                </a:solidFill>
-              </a:rPr>
-              <a:t>All bodies assembled in FreeCAD Assembly with correct spacing and constraints</a:t>
+              <a:t>Four symmetric press-fit pockets at FL, FR, RL, RR corners</a:t>
             </a:r>
           </a:p>
         </p:txBody>
@@ -9118,8 +8924,8 @@
         </p:nvSpPr>
         <p:spPr>
           <a:xfrm>
-            <a:off x="411480" y="1463040"/>
-            <a:ext cx="11338560" cy="548640"/>
+            <a:off x="411480" y="1563953"/>
+            <a:ext cx="11338560" cy="292388"/>
           </a:xfrm>
           <a:prstGeom prst="rect">
             <a:avLst/>
@@ -9134,7 +8940,7 @@
           <a:p>
             <a:pPr algn="l"/>
             <a:r>
-              <a:rPr sz="1200" b="0" i="0">
+              <a:rPr sz="1300" b="0" i="0" dirty="0">
                 <a:solidFill>
                   <a:srgbClr val="FFFFFF"/>
                 </a:solidFill>
@@ -9275,28 +9081,33 @@
         <p:spPr>
           <a:xfrm>
             <a:off x="347472" y="2788920"/>
-            <a:ext cx="1051560" cy="457200"/>
-          </a:xfrm>
-          <a:prstGeom prst="rect">
-            <a:avLst/>
-          </a:prstGeom>
-          <a:noFill/>
-        </p:spPr>
-        <p:txBody>
-          <a:bodyPr wrap="square">
-            <a:spAutoFit/>
-          </a:bodyPr>
-          <a:lstStyle/>
-          <a:p>
-            <a:pPr algn="ctr"/>
-            <a:r>
-              <a:rPr sz="1800" b="1" i="0">
+            <a:ext cx="1051560" cy="369332"/>
+          </a:xfrm>
+          <a:prstGeom prst="rect">
+            <a:avLst/>
+          </a:prstGeom>
+          <a:noFill/>
+        </p:spPr>
+        <p:txBody>
+          <a:bodyPr wrap="square">
+            <a:spAutoFit/>
+          </a:bodyPr>
+          <a:lstStyle/>
+          <a:p>
+            <a:pPr algn="ctr"/>
+            <a:r>
+              <a:rPr lang="en-US" sz="1800" b="1" i="0" dirty="0">
                 <a:solidFill>
                   <a:srgbClr val="F5C518"/>
                 </a:solidFill>
               </a:rPr>
-              <a:t>PLA+</a:t>
-            </a:r>
+              <a:t>ABS</a:t>
+            </a:r>
+            <a:endParaRPr sz="1800" b="1" i="0" dirty="0">
+              <a:solidFill>
+                <a:srgbClr val="F5C518"/>
+              </a:solidFill>
+            </a:endParaRPr>
           </a:p>
         </p:txBody>
       </p:sp>
@@ -9353,7 +9164,7 @@
         <p:spPr>
           <a:xfrm>
             <a:off x="1554480" y="2642616"/>
-            <a:ext cx="4206240" cy="347472"/>
+            <a:ext cx="4206240" cy="276999"/>
           </a:xfrm>
           <a:prstGeom prst="rect">
             <a:avLst/>
@@ -9368,12 +9179,20 @@
           <a:p>
             <a:pPr algn="l"/>
             <a:r>
-              <a:rPr sz="1200" b="1" i="0">
+              <a:rPr lang="en-IN" sz="1200" b="1" i="0" dirty="0">
                 <a:solidFill>
                   <a:srgbClr val="0D2B55"/>
                 </a:solidFill>
               </a:rPr>
-              <a:t>Core Plate, Head Box, Servo Mounts</a:t>
+              <a:t>Core Body</a:t>
+            </a:r>
+            <a:r>
+              <a:rPr sz="1200" b="1" i="0" dirty="0">
+                <a:solidFill>
+                  <a:srgbClr val="0D2B55"/>
+                </a:solidFill>
+              </a:rPr>
+              <a:t>, Head Box</a:t>
             </a:r>
           </a:p>
         </p:txBody>
@@ -9387,7 +9206,7 @@
         <p:spPr>
           <a:xfrm>
             <a:off x="1554480" y="3026664"/>
-            <a:ext cx="4206240" cy="347472"/>
+            <a:ext cx="4206240" cy="276999"/>
           </a:xfrm>
           <a:prstGeom prst="rect">
             <a:avLst/>
@@ -9402,7 +9221,7 @@
           <a:p>
             <a:pPr algn="l"/>
             <a:r>
-              <a:rPr sz="1100" b="0" i="0">
+              <a:rPr sz="1200" b="0" i="0">
                 <a:solidFill>
                   <a:srgbClr val="1A1A2E"/>
                 </a:solidFill>
@@ -9465,28 +9284,33 @@
         <p:spPr>
           <a:xfrm>
             <a:off x="347472" y="3721608"/>
-            <a:ext cx="1051560" cy="457200"/>
-          </a:xfrm>
-          <a:prstGeom prst="rect">
-            <a:avLst/>
-          </a:prstGeom>
-          <a:noFill/>
-        </p:spPr>
-        <p:txBody>
-          <a:bodyPr wrap="square">
-            <a:spAutoFit/>
-          </a:bodyPr>
-          <a:lstStyle/>
-          <a:p>
-            <a:pPr algn="ctr"/>
-            <a:r>
-              <a:rPr sz="1800" b="1" i="0">
+            <a:ext cx="1051560" cy="369332"/>
+          </a:xfrm>
+          <a:prstGeom prst="rect">
+            <a:avLst/>
+          </a:prstGeom>
+          <a:noFill/>
+        </p:spPr>
+        <p:txBody>
+          <a:bodyPr wrap="square">
+            <a:spAutoFit/>
+          </a:bodyPr>
+          <a:lstStyle/>
+          <a:p>
+            <a:pPr algn="ctr"/>
+            <a:r>
+              <a:rPr lang="en-IN" sz="1800" b="1" i="0" dirty="0">
                 <a:solidFill>
                   <a:srgbClr val="F5C518"/>
                 </a:solidFill>
               </a:rPr>
-              <a:t>PETG</a:t>
-            </a:r>
+              <a:t>PLA</a:t>
+            </a:r>
+            <a:endParaRPr sz="1800" b="1" i="0" dirty="0">
+              <a:solidFill>
+                <a:srgbClr val="F5C518"/>
+              </a:solidFill>
+            </a:endParaRPr>
           </a:p>
         </p:txBody>
       </p:sp>
@@ -9543,7 +9367,7 @@
         <p:spPr>
           <a:xfrm>
             <a:off x="1554480" y="3575304"/>
-            <a:ext cx="4206240" cy="347472"/>
+            <a:ext cx="4206240" cy="276999"/>
           </a:xfrm>
           <a:prstGeom prst="rect">
             <a:avLst/>
@@ -9577,7 +9401,7 @@
         <p:spPr>
           <a:xfrm>
             <a:off x="1554480" y="3959352"/>
-            <a:ext cx="4206240" cy="347472"/>
+            <a:ext cx="4206240" cy="276999"/>
           </a:xfrm>
           <a:prstGeom prst="rect">
             <a:avLst/>
@@ -9592,7 +9416,7 @@
           <a:p>
             <a:pPr algn="l"/>
             <a:r>
-              <a:rPr sz="1100" b="0" i="0">
+              <a:rPr sz="1200" b="0" i="0">
                 <a:solidFill>
                   <a:srgbClr val="1A1A2E"/>
                 </a:solidFill>
@@ -10772,6 +10596,31 @@
           </a:p>
         </p:txBody>
       </p:sp>
+      <p:pic>
+        <p:nvPicPr>
+          <p:cNvPr id="125" name="Picture 124" descr="fig1.1.jpeg"/>
+          <p:cNvPicPr>
+            <a:picLocks noChangeAspect="1"/>
+          </p:cNvPicPr>
+          <p:nvPr/>
+        </p:nvPicPr>
+        <p:blipFill>
+          <a:blip r:embed="rId2"/>
+          <a:srcRect t="30195" b="12402"/>
+          <a:stretch>
+            <a:fillRect/>
+          </a:stretch>
+        </p:blipFill>
+        <p:spPr>
+          <a:xfrm>
+            <a:off x="347345" y="4489704"/>
+            <a:ext cx="3840873" cy="1856232"/>
+          </a:xfrm>
+          <a:prstGeom prst="rect">
+            <a:avLst/>
+          </a:prstGeom>
+        </p:spPr>
+      </p:pic>
     </p:spTree>
   </p:cSld>
   <p:clrMapOvr>
@@ -11206,7 +11055,23 @@
                   <a:srgbClr val="1A1A2E"/>
                 </a:solidFill>
               </a:rPr>
-              <a:t>3D Printer (FDM) in the CGEC Lab during fabrication of the Core Plate and Head Box using </a:t>
+              <a:t>3D Printer (FDM) in the CGEC Lab during fabrication of the </a:t>
+            </a:r>
+            <a:r>
+              <a:rPr lang="en-IN" sz="1100" dirty="0">
+                <a:solidFill>
+                  <a:srgbClr val="1A1A2E"/>
+                </a:solidFill>
+              </a:rPr>
+              <a:t>Core Body</a:t>
+            </a:r>
+            <a:r>
+              <a:rPr sz="1100" dirty="0">
+                <a:solidFill>
+                  <a:srgbClr val="1A1A2E"/>
+                </a:solidFill>
+              </a:rPr>
+              <a:t> and Head Box using </a:t>
             </a:r>
             <a:r>
               <a:rPr lang="en-US" sz="1100" dirty="0">
@@ -11224,9 +11089,53 @@
           </a:p>
         </p:txBody>
       </p:sp>
+      <p:sp>
+        <p:nvSpPr>
+          <p:cNvPr id="126" name="TextBox 125"/>
+          <p:cNvSpPr txBox="1"/>
+          <p:nvPr/>
+        </p:nvSpPr>
+        <p:spPr>
+          <a:xfrm>
+            <a:off x="6537960" y="5760720"/>
+            <a:ext cx="4754880" cy="430887"/>
+          </a:xfrm>
+          <a:prstGeom prst="rect">
+            <a:avLst/>
+          </a:prstGeom>
+          <a:noFill/>
+        </p:spPr>
+        <p:txBody>
+          <a:bodyPr wrap="square">
+            <a:spAutoFit/>
+          </a:bodyPr>
+          <a:lstStyle/>
+          <a:p>
+            <a:pPr algn="l"/>
+            <a:r>
+              <a:rPr sz="1100" dirty="0"/>
+              <a:t>Fabricated leg components (Upper and Lower leg segments) printed in magenta </a:t>
+            </a:r>
+            <a:r>
+              <a:rPr lang="en-US" sz="1100" dirty="0"/>
+              <a:t>PLA</a:t>
+            </a:r>
+            <a:r>
+              <a:rPr sz="1100" dirty="0"/>
+              <a:t> for high layer adhesion and impact strength.</a:t>
+            </a:r>
+          </a:p>
+        </p:txBody>
+      </p:sp>
       <p:pic>
         <p:nvPicPr>
-          <p:cNvPr id="125" name="Picture 124" descr="fig1.1.jpeg"/>
+          <p:cNvPr id="3" name="Picture 2">
+            <a:extLst>
+              <a:ext uri="{FF2B5EF4-FFF2-40B4-BE49-F238E27FC236}">
+                <a16:creationId xmlns:a16="http://schemas.microsoft.com/office/drawing/2014/main" id="{1872651C-87DB-76DD-B60B-E4EA601E0FCE}"/>
+              </a:ext>
+            </a:extLst>
+          </p:cNvPr>
           <p:cNvPicPr>
             <a:picLocks noChangeAspect="1"/>
           </p:cNvPicPr>
@@ -11234,58 +11143,21 @@
         </p:nvPicPr>
         <p:blipFill>
           <a:blip r:embed="rId3"/>
+          <a:srcRect l="6699"/>
           <a:stretch>
             <a:fillRect/>
           </a:stretch>
         </p:blipFill>
         <p:spPr>
           <a:xfrm>
-            <a:off x="6492240" y="1666074"/>
-            <a:ext cx="4754880" cy="4003206"/>
+            <a:off x="6583680" y="1645920"/>
+            <a:ext cx="4663440" cy="4023360"/>
           </a:xfrm>
           <a:prstGeom prst="rect">
             <a:avLst/>
           </a:prstGeom>
         </p:spPr>
       </p:pic>
-      <p:sp>
-        <p:nvSpPr>
-          <p:cNvPr id="126" name="TextBox 125"/>
-          <p:cNvSpPr txBox="1"/>
-          <p:nvPr/>
-        </p:nvSpPr>
-        <p:spPr>
-          <a:xfrm>
-            <a:off x="6537960" y="5760720"/>
-            <a:ext cx="4754880" cy="430887"/>
-          </a:xfrm>
-          <a:prstGeom prst="rect">
-            <a:avLst/>
-          </a:prstGeom>
-          <a:noFill/>
-        </p:spPr>
-        <p:txBody>
-          <a:bodyPr wrap="square">
-            <a:spAutoFit/>
-          </a:bodyPr>
-          <a:lstStyle/>
-          <a:p>
-            <a:pPr algn="l"/>
-            <a:r>
-              <a:rPr sz="1100" dirty="0"/>
-              <a:t>Fabricated leg components (Upper and Lower leg segments) printed in magenta </a:t>
-            </a:r>
-            <a:r>
-              <a:rPr lang="en-US" sz="1100" dirty="0"/>
-              <a:t>PLA+</a:t>
-            </a:r>
-            <a:r>
-              <a:rPr sz="1100" dirty="0"/>
-              <a:t> for high layer adhesion and impact strength.</a:t>
-            </a:r>
-          </a:p>
-        </p:txBody>
-      </p:sp>
     </p:spTree>
   </p:cSld>
   <p:clrMapOvr>
@@ -12110,7 +11982,7 @@
         <p:spPr>
           <a:xfrm>
             <a:off x="374904" y="1984248"/>
-            <a:ext cx="1371600" cy="640080"/>
+            <a:ext cx="1371600" cy="292388"/>
           </a:xfrm>
           <a:prstGeom prst="rect">
             <a:avLst/>
@@ -12125,13 +11997,26 @@
           <a:p>
             <a:pPr algn="l"/>
             <a:r>
-              <a:rPr sz="1300" b="1" i="0">
+              <a:rPr sz="1300" b="1" i="0" dirty="0">
                 <a:solidFill>
                   <a:srgbClr val="1A1A2E"/>
                 </a:solidFill>
               </a:rPr>
-              <a:t>Core Plate</a:t>
-            </a:r>
+              <a:t>Core </a:t>
+            </a:r>
+            <a:r>
+              <a:rPr lang="en-US" sz="1300" b="1" i="0" dirty="0">
+                <a:solidFill>
+                  <a:srgbClr val="1A1A2E"/>
+                </a:solidFill>
+              </a:rPr>
+              <a:t>Body</a:t>
+            </a:r>
+            <a:endParaRPr sz="1300" b="1" i="0" dirty="0">
+              <a:solidFill>
+                <a:srgbClr val="1A1A2E"/>
+              </a:solidFill>
+            </a:endParaRPr>
           </a:p>
         </p:txBody>
       </p:sp>
@@ -12286,7 +12171,7 @@
           <a:p>
             <a:pPr algn="l"/>
             <a:r>
-              <a:rPr sz="1200" b="0" i="0">
+              <a:rPr sz="1200" b="0" i="0" dirty="0">
                 <a:solidFill>
                   <a:srgbClr val="1A1A2E"/>
                 </a:solidFill>
@@ -12427,7 +12312,7 @@
         <p:spPr>
           <a:xfrm>
             <a:off x="5769864" y="1984248"/>
-            <a:ext cx="6080760" cy="640080"/>
+            <a:ext cx="6080760" cy="261610"/>
           </a:xfrm>
           <a:prstGeom prst="rect">
             <a:avLst/>
@@ -12442,12 +12327,12 @@
           <a:p>
             <a:pPr algn="l"/>
             <a:r>
-              <a:rPr sz="1100" b="0" i="0">
+              <a:rPr sz="1100" b="0" i="0" dirty="0">
                 <a:solidFill>
                   <a:srgbClr val="1A1A2E"/>
                 </a:solidFill>
               </a:rPr>
-              <a:t>Central chassis; 4 hip mounts + 1 head servo mount; 4mm thickness for bending rigidity</a:t>
+              <a:t>Central chassis; 4 hip mounts; 4mm thickness for bending rigidity</a:t>
             </a:r>
           </a:p>
         </p:txBody>
@@ -12681,7 +12566,7 @@
           <a:p>
             <a:pPr algn="l"/>
             <a:r>
-              <a:rPr sz="1200" b="0" i="0">
+              <a:rPr sz="1200" b="0" i="0" dirty="0">
                 <a:solidFill>
                   <a:srgbClr val="1A1A2E"/>
                 </a:solidFill>
@@ -12998,7 +12883,7 @@
                   <a:srgbClr val="176B47"/>
                 </a:solidFill>
               </a:rPr>
-              <a:t>PLA+</a:t>
+              <a:t>PLA</a:t>
             </a:r>
             <a:endParaRPr sz="1200" b="0" i="0" dirty="0">
               <a:solidFill>
@@ -13076,7 +12961,7 @@
           <a:p>
             <a:pPr algn="l"/>
             <a:r>
-              <a:rPr sz="1200" b="0" i="0">
+              <a:rPr sz="1200" b="0" i="0" dirty="0">
                 <a:solidFill>
                   <a:srgbClr val="1A1A2E"/>
                 </a:solidFill>
@@ -13232,7 +13117,7 @@
           <a:p>
             <a:pPr algn="l"/>
             <a:r>
-              <a:rPr sz="1100" b="0" i="0">
+              <a:rPr sz="1100" b="0" i="0" dirty="0">
                 <a:solidFill>
                   <a:srgbClr val="1A1A2E"/>
                 </a:solidFill>
@@ -13393,7 +13278,7 @@
                   <a:srgbClr val="176B47"/>
                 </a:solidFill>
               </a:rPr>
-              <a:t>PLA+</a:t>
+              <a:t>PLA</a:t>
             </a:r>
             <a:endParaRPr sz="1200" b="0" i="0" dirty="0">
               <a:solidFill>
@@ -13471,7 +13356,7 @@
           <a:p>
             <a:pPr algn="l"/>
             <a:r>
-              <a:rPr sz="1200" b="0" i="0">
+              <a:rPr sz="1200" b="0" i="0" dirty="0">
                 <a:solidFill>
                   <a:srgbClr val="1A1A2E"/>
                 </a:solidFill>
@@ -13633,401 +13518,6 @@
                 </a:solidFill>
               </a:rPr>
               <a:t>Knee-servo driven link; foot pad boss at distal terminal end</a:t>
-            </a:r>
-          </a:p>
-        </p:txBody>
-      </p:sp>
-      <p:sp>
-        <p:nvSpPr>
-          <p:cNvPr id="61" name="Rectangle 60"/>
-          <p:cNvSpPr/>
-          <p:nvPr/>
-        </p:nvSpPr>
-        <p:spPr>
-          <a:xfrm>
-            <a:off x="320040" y="5367527"/>
-            <a:ext cx="1463040" cy="804672"/>
-          </a:xfrm>
-          <a:prstGeom prst="rect">
-            <a:avLst/>
-          </a:prstGeom>
-          <a:solidFill>
-            <a:srgbClr val="E8F0FB"/>
-          </a:solidFill>
-          <a:ln>
-            <a:noFill/>
-          </a:ln>
-        </p:spPr>
-        <p:style>
-          <a:lnRef idx="1">
-            <a:schemeClr val="accent1"/>
-          </a:lnRef>
-          <a:fillRef idx="3">
-            <a:schemeClr val="accent1"/>
-          </a:fillRef>
-          <a:effectRef idx="2">
-            <a:schemeClr val="accent1"/>
-          </a:effectRef>
-          <a:fontRef idx="minor">
-            <a:schemeClr val="lt1"/>
-          </a:fontRef>
-        </p:style>
-        <p:txBody>
-          <a:bodyPr rtlCol="0" anchor="ctr"/>
-          <a:lstStyle/>
-          <a:p>
-            <a:pPr algn="ctr"/>
-            <a:endParaRPr/>
-          </a:p>
-        </p:txBody>
-      </p:sp>
-      <p:sp>
-        <p:nvSpPr>
-          <p:cNvPr id="62" name="TextBox 61"/>
-          <p:cNvSpPr txBox="1"/>
-          <p:nvPr/>
-        </p:nvSpPr>
-        <p:spPr>
-          <a:xfrm>
-            <a:off x="374904" y="5458967"/>
-            <a:ext cx="1371600" cy="640080"/>
-          </a:xfrm>
-          <a:prstGeom prst="rect">
-            <a:avLst/>
-          </a:prstGeom>
-          <a:noFill/>
-        </p:spPr>
-        <p:txBody>
-          <a:bodyPr wrap="square">
-            <a:spAutoFit/>
-          </a:bodyPr>
-          <a:lstStyle/>
-          <a:p>
-            <a:pPr algn="l"/>
-            <a:r>
-              <a:rPr sz="1300" b="1" i="0">
-                <a:solidFill>
-                  <a:srgbClr val="1A1A2E"/>
-                </a:solidFill>
-              </a:rPr>
-              <a:t>Servo Mount</a:t>
-            </a:r>
-          </a:p>
-        </p:txBody>
-      </p:sp>
-      <p:sp>
-        <p:nvSpPr>
-          <p:cNvPr id="63" name="Rectangle 62"/>
-          <p:cNvSpPr/>
-          <p:nvPr/>
-        </p:nvSpPr>
-        <p:spPr>
-          <a:xfrm>
-            <a:off x="1828800" y="5367527"/>
-            <a:ext cx="1371600" cy="804672"/>
-          </a:xfrm>
-          <a:prstGeom prst="rect">
-            <a:avLst/>
-          </a:prstGeom>
-          <a:solidFill>
-            <a:srgbClr val="E8F0FB"/>
-          </a:solidFill>
-          <a:ln>
-            <a:noFill/>
-          </a:ln>
-        </p:spPr>
-        <p:style>
-          <a:lnRef idx="1">
-            <a:schemeClr val="accent1"/>
-          </a:lnRef>
-          <a:fillRef idx="3">
-            <a:schemeClr val="accent1"/>
-          </a:fillRef>
-          <a:effectRef idx="2">
-            <a:schemeClr val="accent1"/>
-          </a:effectRef>
-          <a:fontRef idx="minor">
-            <a:schemeClr val="lt1"/>
-          </a:fontRef>
-        </p:style>
-        <p:txBody>
-          <a:bodyPr rtlCol="0" anchor="ctr"/>
-          <a:lstStyle/>
-          <a:p>
-            <a:pPr algn="ctr"/>
-            <a:endParaRPr/>
-          </a:p>
-        </p:txBody>
-      </p:sp>
-      <p:sp>
-        <p:nvSpPr>
-          <p:cNvPr id="64" name="TextBox 63"/>
-          <p:cNvSpPr txBox="1"/>
-          <p:nvPr/>
-        </p:nvSpPr>
-        <p:spPr>
-          <a:xfrm>
-            <a:off x="1883664" y="5458967"/>
-            <a:ext cx="1280160" cy="276999"/>
-          </a:xfrm>
-          <a:prstGeom prst="rect">
-            <a:avLst/>
-          </a:prstGeom>
-          <a:noFill/>
-        </p:spPr>
-        <p:txBody>
-          <a:bodyPr wrap="square">
-            <a:spAutoFit/>
-          </a:bodyPr>
-          <a:lstStyle/>
-          <a:p>
-            <a:pPr algn="l"/>
-            <a:r>
-              <a:rPr lang="en-US" sz="1200" b="0" i="0" dirty="0">
-                <a:solidFill>
-                  <a:srgbClr val="C02020"/>
-                </a:solidFill>
-              </a:rPr>
-              <a:t>ABS</a:t>
-            </a:r>
-            <a:endParaRPr sz="1200" b="0" i="0" dirty="0">
-              <a:solidFill>
-                <a:srgbClr val="C02020"/>
-              </a:solidFill>
-            </a:endParaRPr>
-          </a:p>
-        </p:txBody>
-      </p:sp>
-      <p:sp>
-        <p:nvSpPr>
-          <p:cNvPr id="65" name="Rectangle 64"/>
-          <p:cNvSpPr/>
-          <p:nvPr/>
-        </p:nvSpPr>
-        <p:spPr>
-          <a:xfrm>
-            <a:off x="3246120" y="5367527"/>
-            <a:ext cx="1783080" cy="804672"/>
-          </a:xfrm>
-          <a:prstGeom prst="rect">
-            <a:avLst/>
-          </a:prstGeom>
-          <a:solidFill>
-            <a:srgbClr val="E8F0FB"/>
-          </a:solidFill>
-          <a:ln>
-            <a:noFill/>
-          </a:ln>
-        </p:spPr>
-        <p:style>
-          <a:lnRef idx="1">
-            <a:schemeClr val="accent1"/>
-          </a:lnRef>
-          <a:fillRef idx="3">
-            <a:schemeClr val="accent1"/>
-          </a:fillRef>
-          <a:effectRef idx="2">
-            <a:schemeClr val="accent1"/>
-          </a:effectRef>
-          <a:fontRef idx="minor">
-            <a:schemeClr val="lt1"/>
-          </a:fontRef>
-        </p:style>
-        <p:txBody>
-          <a:bodyPr rtlCol="0" anchor="ctr"/>
-          <a:lstStyle/>
-          <a:p>
-            <a:pPr algn="ctr"/>
-            <a:endParaRPr/>
-          </a:p>
-        </p:txBody>
-      </p:sp>
-      <p:sp>
-        <p:nvSpPr>
-          <p:cNvPr id="66" name="TextBox 65"/>
-          <p:cNvSpPr txBox="1"/>
-          <p:nvPr/>
-        </p:nvSpPr>
-        <p:spPr>
-          <a:xfrm>
-            <a:off x="3300984" y="5458967"/>
-            <a:ext cx="1691639" cy="640080"/>
-          </a:xfrm>
-          <a:prstGeom prst="rect">
-            <a:avLst/>
-          </a:prstGeom>
-          <a:noFill/>
-        </p:spPr>
-        <p:txBody>
-          <a:bodyPr wrap="square">
-            <a:spAutoFit/>
-          </a:bodyPr>
-          <a:lstStyle/>
-          <a:p>
-            <a:pPr algn="l"/>
-            <a:r>
-              <a:rPr sz="1200" b="0" i="0">
-                <a:solidFill>
-                  <a:srgbClr val="1A1A2E"/>
-                </a:solidFill>
-              </a:rPr>
-              <a:t>Custom fit</a:t>
-            </a:r>
-          </a:p>
-        </p:txBody>
-      </p:sp>
-      <p:sp>
-        <p:nvSpPr>
-          <p:cNvPr id="67" name="Rectangle 66"/>
-          <p:cNvSpPr/>
-          <p:nvPr/>
-        </p:nvSpPr>
-        <p:spPr>
-          <a:xfrm>
-            <a:off x="5074920" y="5367527"/>
-            <a:ext cx="594360" cy="804672"/>
-          </a:xfrm>
-          <a:prstGeom prst="rect">
-            <a:avLst/>
-          </a:prstGeom>
-          <a:solidFill>
-            <a:srgbClr val="E8F0FB"/>
-          </a:solidFill>
-          <a:ln>
-            <a:noFill/>
-          </a:ln>
-        </p:spPr>
-        <p:style>
-          <a:lnRef idx="1">
-            <a:schemeClr val="accent1"/>
-          </a:lnRef>
-          <a:fillRef idx="3">
-            <a:schemeClr val="accent1"/>
-          </a:fillRef>
-          <a:effectRef idx="2">
-            <a:schemeClr val="accent1"/>
-          </a:effectRef>
-          <a:fontRef idx="minor">
-            <a:schemeClr val="lt1"/>
-          </a:fontRef>
-        </p:style>
-        <p:txBody>
-          <a:bodyPr rtlCol="0" anchor="ctr"/>
-          <a:lstStyle/>
-          <a:p>
-            <a:pPr algn="ctr"/>
-            <a:endParaRPr/>
-          </a:p>
-        </p:txBody>
-      </p:sp>
-      <p:sp>
-        <p:nvSpPr>
-          <p:cNvPr id="68" name="TextBox 67"/>
-          <p:cNvSpPr txBox="1"/>
-          <p:nvPr/>
-        </p:nvSpPr>
-        <p:spPr>
-          <a:xfrm>
-            <a:off x="5129783" y="5458967"/>
-            <a:ext cx="502920" cy="640080"/>
-          </a:xfrm>
-          <a:prstGeom prst="rect">
-            <a:avLst/>
-          </a:prstGeom>
-          <a:noFill/>
-        </p:spPr>
-        <p:txBody>
-          <a:bodyPr wrap="square">
-            <a:spAutoFit/>
-          </a:bodyPr>
-          <a:lstStyle/>
-          <a:p>
-            <a:pPr algn="l"/>
-            <a:r>
-              <a:rPr sz="1200" b="0" i="0">
-                <a:solidFill>
-                  <a:srgbClr val="1A1A2E"/>
-                </a:solidFill>
-              </a:rPr>
-              <a:t>9</a:t>
-            </a:r>
-          </a:p>
-        </p:txBody>
-      </p:sp>
-      <p:sp>
-        <p:nvSpPr>
-          <p:cNvPr id="69" name="Rectangle 68"/>
-          <p:cNvSpPr/>
-          <p:nvPr/>
-        </p:nvSpPr>
-        <p:spPr>
-          <a:xfrm>
-            <a:off x="5715000" y="5367527"/>
-            <a:ext cx="6172200" cy="804672"/>
-          </a:xfrm>
-          <a:prstGeom prst="rect">
-            <a:avLst/>
-          </a:prstGeom>
-          <a:solidFill>
-            <a:srgbClr val="E8F0FB"/>
-          </a:solidFill>
-          <a:ln>
-            <a:noFill/>
-          </a:ln>
-        </p:spPr>
-        <p:style>
-          <a:lnRef idx="1">
-            <a:schemeClr val="accent1"/>
-          </a:lnRef>
-          <a:fillRef idx="3">
-            <a:schemeClr val="accent1"/>
-          </a:fillRef>
-          <a:effectRef idx="2">
-            <a:schemeClr val="accent1"/>
-          </a:effectRef>
-          <a:fontRef idx="minor">
-            <a:schemeClr val="lt1"/>
-          </a:fontRef>
-        </p:style>
-        <p:txBody>
-          <a:bodyPr rtlCol="0" anchor="ctr"/>
-          <a:lstStyle/>
-          <a:p>
-            <a:pPr algn="ctr"/>
-            <a:endParaRPr/>
-          </a:p>
-        </p:txBody>
-      </p:sp>
-      <p:sp>
-        <p:nvSpPr>
-          <p:cNvPr id="70" name="TextBox 69"/>
-          <p:cNvSpPr txBox="1"/>
-          <p:nvPr/>
-        </p:nvSpPr>
-        <p:spPr>
-          <a:xfrm>
-            <a:off x="5769864" y="5458967"/>
-            <a:ext cx="6080760" cy="640080"/>
-          </a:xfrm>
-          <a:prstGeom prst="rect">
-            <a:avLst/>
-          </a:prstGeom>
-          <a:noFill/>
-        </p:spPr>
-        <p:txBody>
-          <a:bodyPr wrap="square">
-            <a:spAutoFit/>
-          </a:bodyPr>
-          <a:lstStyle/>
-          <a:p>
-            <a:pPr algn="l"/>
-            <a:r>
-              <a:rPr sz="1100" b="0" i="0">
-                <a:solidFill>
-                  <a:srgbClr val="1A1A2E"/>
-                </a:solidFill>
-              </a:rPr>
-              <a:t>Press-fit housing for MG90S servo body; one per servo</a:t>
             </a:r>
           </a:p>
         </p:txBody>
@@ -16915,7 +16405,7 @@
         <p:spPr>
           <a:xfrm>
             <a:off x="6099048" y="1444752"/>
-            <a:ext cx="5742432" cy="329184"/>
+            <a:ext cx="5742432" cy="276999"/>
           </a:xfrm>
           <a:prstGeom prst="rect">
             <a:avLst/>
@@ -16930,12 +16420,28 @@
           <a:p>
             <a:pPr algn="l"/>
             <a:r>
-              <a:rPr sz="1200" b="1" i="0">
+              <a:rPr sz="1200" b="1" i="0" dirty="0">
                 <a:solidFill>
                   <a:srgbClr val="FFFFFF"/>
                 </a:solidFill>
               </a:rPr>
-              <a:t>Individual Servo Test Results (All 9 Passed)</a:t>
+              <a:t>Individual Servo Test Results (All </a:t>
+            </a:r>
+            <a:r>
+              <a:rPr lang="en-US" sz="1200" b="1" i="0" dirty="0">
+                <a:solidFill>
+                  <a:srgbClr val="FFFFFF"/>
+                </a:solidFill>
+              </a:rPr>
+              <a:t>8</a:t>
+            </a:r>
+            <a:r>
+              <a:rPr sz="1200" b="1" i="0" dirty="0">
+                <a:solidFill>
+                  <a:srgbClr val="FFFFFF"/>
+                </a:solidFill>
+              </a:rPr>
+              <a:t> Passed)</a:t>
             </a:r>
           </a:p>
         </p:txBody>
@@ -19723,318 +19229,6 @@
         <p:spPr>
           <a:xfrm>
             <a:off x="10689336" y="5230368"/>
-            <a:ext cx="713232" cy="274320"/>
-          </a:xfrm>
-          <a:prstGeom prst="rect">
-            <a:avLst/>
-          </a:prstGeom>
-          <a:noFill/>
-        </p:spPr>
-        <p:txBody>
-          <a:bodyPr wrap="square">
-            <a:spAutoFit/>
-          </a:bodyPr>
-          <a:lstStyle/>
-          <a:p>
-            <a:pPr algn="ctr"/>
-            <a:r>
-              <a:rPr sz="1000" b="1" i="0">
-                <a:solidFill>
-                  <a:srgbClr val="1E8B4C"/>
-                </a:solidFill>
-              </a:rPr>
-              <a:t>✓ Pass</a:t>
-            </a:r>
-          </a:p>
-        </p:txBody>
-      </p:sp>
-      <p:sp>
-        <p:nvSpPr>
-          <p:cNvPr id="93" name="Rectangle 92"/>
-          <p:cNvSpPr/>
-          <p:nvPr/>
-        </p:nvSpPr>
-        <p:spPr>
-          <a:xfrm>
-            <a:off x="6035040" y="5596128"/>
-            <a:ext cx="475488" cy="384048"/>
-          </a:xfrm>
-          <a:prstGeom prst="rect">
-            <a:avLst/>
-          </a:prstGeom>
-          <a:solidFill>
-            <a:srgbClr val="E8F0FB"/>
-          </a:solidFill>
-          <a:ln>
-            <a:noFill/>
-          </a:ln>
-        </p:spPr>
-        <p:style>
-          <a:lnRef idx="1">
-            <a:schemeClr val="accent1"/>
-          </a:lnRef>
-          <a:fillRef idx="3">
-            <a:schemeClr val="accent1"/>
-          </a:fillRef>
-          <a:effectRef idx="2">
-            <a:schemeClr val="accent1"/>
-          </a:effectRef>
-          <a:fontRef idx="minor">
-            <a:schemeClr val="lt1"/>
-          </a:fontRef>
-        </p:style>
-        <p:txBody>
-          <a:bodyPr rtlCol="0" anchor="ctr"/>
-          <a:lstStyle/>
-          <a:p>
-            <a:pPr algn="ctr"/>
-            <a:endParaRPr/>
-          </a:p>
-        </p:txBody>
-      </p:sp>
-      <p:sp>
-        <p:nvSpPr>
-          <p:cNvPr id="94" name="TextBox 93"/>
-          <p:cNvSpPr txBox="1"/>
-          <p:nvPr/>
-        </p:nvSpPr>
-        <p:spPr>
-          <a:xfrm>
-            <a:off x="6071616" y="5650992"/>
-            <a:ext cx="420624" cy="274320"/>
-          </a:xfrm>
-          <a:prstGeom prst="rect">
-            <a:avLst/>
-          </a:prstGeom>
-          <a:noFill/>
-        </p:spPr>
-        <p:txBody>
-          <a:bodyPr wrap="square">
-            <a:spAutoFit/>
-          </a:bodyPr>
-          <a:lstStyle/>
-          <a:p>
-            <a:pPr algn="ctr"/>
-            <a:r>
-              <a:rPr sz="1100" b="1" i="0">
-                <a:solidFill>
-                  <a:srgbClr val="0D2B55"/>
-                </a:solidFill>
-              </a:rPr>
-              <a:t>9</a:t>
-            </a:r>
-          </a:p>
-        </p:txBody>
-      </p:sp>
-      <p:sp>
-        <p:nvSpPr>
-          <p:cNvPr id="95" name="Rectangle 94"/>
-          <p:cNvSpPr/>
-          <p:nvPr/>
-        </p:nvSpPr>
-        <p:spPr>
-          <a:xfrm>
-            <a:off x="6537960" y="5596128"/>
-            <a:ext cx="3291840" cy="384048"/>
-          </a:xfrm>
-          <a:prstGeom prst="rect">
-            <a:avLst/>
-          </a:prstGeom>
-          <a:solidFill>
-            <a:srgbClr val="E8F0FB"/>
-          </a:solidFill>
-          <a:ln>
-            <a:noFill/>
-          </a:ln>
-        </p:spPr>
-        <p:style>
-          <a:lnRef idx="1">
-            <a:schemeClr val="accent1"/>
-          </a:lnRef>
-          <a:fillRef idx="3">
-            <a:schemeClr val="accent1"/>
-          </a:fillRef>
-          <a:effectRef idx="2">
-            <a:schemeClr val="accent1"/>
-          </a:effectRef>
-          <a:fontRef idx="minor">
-            <a:schemeClr val="lt1"/>
-          </a:fontRef>
-        </p:style>
-        <p:txBody>
-          <a:bodyPr rtlCol="0" anchor="ctr"/>
-          <a:lstStyle/>
-          <a:p>
-            <a:pPr algn="ctr"/>
-            <a:endParaRPr/>
-          </a:p>
-        </p:txBody>
-      </p:sp>
-      <p:sp>
-        <p:nvSpPr>
-          <p:cNvPr id="96" name="TextBox 95"/>
-          <p:cNvSpPr txBox="1"/>
-          <p:nvPr/>
-        </p:nvSpPr>
-        <p:spPr>
-          <a:xfrm>
-            <a:off x="6592824" y="5650992"/>
-            <a:ext cx="3200400" cy="274320"/>
-          </a:xfrm>
-          <a:prstGeom prst="rect">
-            <a:avLst/>
-          </a:prstGeom>
-          <a:noFill/>
-        </p:spPr>
-        <p:txBody>
-          <a:bodyPr wrap="square">
-            <a:spAutoFit/>
-          </a:bodyPr>
-          <a:lstStyle/>
-          <a:p>
-            <a:pPr algn="l"/>
-            <a:r>
-              <a:rPr sz="1100" b="0" i="0">
-                <a:solidFill>
-                  <a:srgbClr val="1A1A2E"/>
-                </a:solidFill>
-              </a:rPr>
-              <a:t>Head Rotation (CH8)</a:t>
-            </a:r>
-          </a:p>
-        </p:txBody>
-      </p:sp>
-      <p:sp>
-        <p:nvSpPr>
-          <p:cNvPr id="97" name="Rectangle 96"/>
-          <p:cNvSpPr/>
-          <p:nvPr/>
-        </p:nvSpPr>
-        <p:spPr>
-          <a:xfrm>
-            <a:off x="9857232" y="5596128"/>
-            <a:ext cx="768096" cy="384048"/>
-          </a:xfrm>
-          <a:prstGeom prst="rect">
-            <a:avLst/>
-          </a:prstGeom>
-          <a:solidFill>
-            <a:srgbClr val="E8F0FB"/>
-          </a:solidFill>
-          <a:ln>
-            <a:noFill/>
-          </a:ln>
-        </p:spPr>
-        <p:style>
-          <a:lnRef idx="1">
-            <a:schemeClr val="accent1"/>
-          </a:lnRef>
-          <a:fillRef idx="3">
-            <a:schemeClr val="accent1"/>
-          </a:fillRef>
-          <a:effectRef idx="2">
-            <a:schemeClr val="accent1"/>
-          </a:effectRef>
-          <a:fontRef idx="minor">
-            <a:schemeClr val="lt1"/>
-          </a:fontRef>
-        </p:style>
-        <p:txBody>
-          <a:bodyPr rtlCol="0" anchor="ctr"/>
-          <a:lstStyle/>
-          <a:p>
-            <a:pPr algn="ctr"/>
-            <a:endParaRPr/>
-          </a:p>
-        </p:txBody>
-      </p:sp>
-      <p:sp>
-        <p:nvSpPr>
-          <p:cNvPr id="98" name="TextBox 97"/>
-          <p:cNvSpPr txBox="1"/>
-          <p:nvPr/>
-        </p:nvSpPr>
-        <p:spPr>
-          <a:xfrm>
-            <a:off x="9893807" y="5650992"/>
-            <a:ext cx="713232" cy="274320"/>
-          </a:xfrm>
-          <a:prstGeom prst="rect">
-            <a:avLst/>
-          </a:prstGeom>
-          <a:noFill/>
-        </p:spPr>
-        <p:txBody>
-          <a:bodyPr wrap="square">
-            <a:spAutoFit/>
-          </a:bodyPr>
-          <a:lstStyle/>
-          <a:p>
-            <a:pPr algn="ctr"/>
-            <a:r>
-              <a:rPr sz="1000" b="1" i="0">
-                <a:solidFill>
-                  <a:srgbClr val="1E8B4C"/>
-                </a:solidFill>
-              </a:rPr>
-              <a:t>✓ Pass</a:t>
-            </a:r>
-          </a:p>
-        </p:txBody>
-      </p:sp>
-      <p:sp>
-        <p:nvSpPr>
-          <p:cNvPr id="99" name="Rectangle 98"/>
-          <p:cNvSpPr/>
-          <p:nvPr/>
-        </p:nvSpPr>
-        <p:spPr>
-          <a:xfrm>
-            <a:off x="10652760" y="5596128"/>
-            <a:ext cx="768096" cy="384048"/>
-          </a:xfrm>
-          <a:prstGeom prst="rect">
-            <a:avLst/>
-          </a:prstGeom>
-          <a:solidFill>
-            <a:srgbClr val="E8F0FB"/>
-          </a:solidFill>
-          <a:ln>
-            <a:noFill/>
-          </a:ln>
-        </p:spPr>
-        <p:style>
-          <a:lnRef idx="1">
-            <a:schemeClr val="accent1"/>
-          </a:lnRef>
-          <a:fillRef idx="3">
-            <a:schemeClr val="accent1"/>
-          </a:fillRef>
-          <a:effectRef idx="2">
-            <a:schemeClr val="accent1"/>
-          </a:effectRef>
-          <a:fontRef idx="minor">
-            <a:schemeClr val="lt1"/>
-          </a:fontRef>
-        </p:style>
-        <p:txBody>
-          <a:bodyPr rtlCol="0" anchor="ctr"/>
-          <a:lstStyle/>
-          <a:p>
-            <a:pPr algn="ctr"/>
-            <a:endParaRPr/>
-          </a:p>
-        </p:txBody>
-      </p:sp>
-      <p:sp>
-        <p:nvSpPr>
-          <p:cNvPr id="100" name="TextBox 99"/>
-          <p:cNvSpPr txBox="1"/>
-          <p:nvPr/>
-        </p:nvSpPr>
-        <p:spPr>
-          <a:xfrm>
-            <a:off x="10689336" y="5650992"/>
             <a:ext cx="713232" cy="274320"/>
           </a:xfrm>
           <a:prstGeom prst="rect">
@@ -23201,7 +22395,23 @@
                   <a:srgbClr val="1A1A2E"/>
                 </a:solidFill>
               </a:rPr>
-              <a:t>Systematic debugging validated: I2C chain, servo power rail fix, all 9 servos operational across full 0°–180° range</a:t>
+              <a:t>Systematic debugging validated: I2C chain, servo power rail fix, all </a:t>
+            </a:r>
+            <a:r>
+              <a:rPr lang="en-US" sz="1400" b="0" i="0" dirty="0">
+                <a:solidFill>
+                  <a:srgbClr val="1A1A2E"/>
+                </a:solidFill>
+              </a:rPr>
+              <a:t>8</a:t>
+            </a:r>
+            <a:r>
+              <a:rPr sz="1400" b="0" i="0" dirty="0">
+                <a:solidFill>
+                  <a:srgbClr val="1A1A2E"/>
+                </a:solidFill>
+              </a:rPr>
+              <a:t> servos operational across full 0°–180° range</a:t>
             </a:r>
           </a:p>
         </p:txBody>
@@ -23337,7 +22547,7 @@
         <p:spPr>
           <a:xfrm>
             <a:off x="2743200" y="2664333"/>
-            <a:ext cx="9006840" cy="523220"/>
+            <a:ext cx="9006840" cy="307777"/>
           </a:xfrm>
           <a:prstGeom prst="rect">
             <a:avLst/>
@@ -23357,7 +22567,7 @@
                   <a:srgbClr val="1A1A2E"/>
                 </a:solidFill>
               </a:rPr>
-              <a:t>Parametric FreeCAD CAD workflow mastered: servo mounts, press-fit tolerances, STL export → design-for-manufacture skills</a:t>
+              <a:t>Parametric FreeCAD CAD workflow mastered: , press-fit tolerances, STL export → design-for-manufacture skills</a:t>
             </a:r>
           </a:p>
         </p:txBody>
@@ -23513,7 +22723,15 @@
                   <a:srgbClr val="1A1A2E"/>
                 </a:solidFill>
               </a:rPr>
-              <a:t>Hands-on material selection (PLA+</a:t>
+              <a:t>Hands-on material selection (PLA</a:t>
+            </a:r>
+            <a:r>
+              <a:rPr lang="en-US" sz="1400" dirty="0">
+                <a:solidFill>
+                  <a:srgbClr val="1A1A2E"/>
+                </a:solidFill>
+              </a:rPr>
+              <a:t> </a:t>
             </a:r>
             <a:r>
               <a:rPr lang="en-US" sz="1400" b="0" i="0" dirty="0">
@@ -23521,23 +22739,7 @@
                   <a:srgbClr val="1A1A2E"/>
                 </a:solidFill>
               </a:rPr>
-              <a:t>, </a:t>
-            </a:r>
-            <a:r>
-              <a:rPr sz="1400" b="0" i="0" dirty="0">
-                <a:solidFill>
-                  <a:srgbClr val="1A1A2E"/>
-                </a:solidFill>
-              </a:rPr>
-              <a:t>PETG</a:t>
-            </a:r>
-            <a:r>
-              <a:rPr lang="en-US" sz="1400" b="0" i="0" dirty="0">
-                <a:solidFill>
-                  <a:srgbClr val="1A1A2E"/>
-                </a:solidFill>
-              </a:rPr>
-              <a:t> &amp; ABS</a:t>
+              <a:t>&amp; ABS</a:t>
             </a:r>
             <a:r>
               <a:rPr sz="1400" b="0" i="0" dirty="0">
@@ -29099,7 +28301,23 @@
                   <a:srgbClr val="1A1A2E"/>
                 </a:solidFill>
               </a:rPr>
-              <a:t>Tower Pro, MG90S Metal Gear Micro Servo Datasheet, Tower Pro Co. Ltd., 2020</a:t>
+              <a:t>Tower Pro, </a:t>
+            </a:r>
+            <a:r>
+              <a:rPr lang="en-IN" sz="1400" b="0" i="0" dirty="0">
+                <a:solidFill>
+                  <a:srgbClr val="1A1A2E"/>
+                </a:solidFill>
+              </a:rPr>
+              <a:t>SG90</a:t>
+            </a:r>
+            <a:r>
+              <a:rPr sz="1400" b="0" i="0" dirty="0">
+                <a:solidFill>
+                  <a:srgbClr val="1A1A2E"/>
+                </a:solidFill>
+              </a:rPr>
+              <a:t>S Metal Gear Micro Servo Datasheet, Tower Pro Co. Ltd., 2020</a:t>
             </a:r>
           </a:p>
         </p:txBody>
@@ -30235,7 +29453,7 @@
         <p:spPr>
           <a:xfrm>
             <a:off x="822960" y="2304288"/>
-            <a:ext cx="10881360" cy="402336"/>
+            <a:ext cx="10881360" cy="307777"/>
           </a:xfrm>
           <a:prstGeom prst="rect">
             <a:avLst/>
@@ -30250,12 +29468,44 @@
           <a:p>
             <a:pPr algn="l"/>
             <a:r>
-              <a:rPr sz="1400" b="0" i="0">
+              <a:rPr sz="1400" b="0" i="0" dirty="0">
                 <a:solidFill>
                   <a:srgbClr val="1A1A2E"/>
                 </a:solidFill>
               </a:rPr>
-              <a:t>Core hardware: ESP32 microcontroller  |  PCA9685 16-ch servo driver  |  9× MG90S servos</a:t>
+              <a:t>Core hardware: ESP32 microcontroller  |  PCA9685 16-ch servo driver  |  </a:t>
+            </a:r>
+            <a:r>
+              <a:rPr lang="en-US" sz="1400" b="0" i="0" dirty="0">
+                <a:solidFill>
+                  <a:srgbClr val="1A1A2E"/>
+                </a:solidFill>
+              </a:rPr>
+              <a:t>8 </a:t>
+            </a:r>
+            <a:r>
+              <a:rPr sz="1400" b="0" i="0" dirty="0">
+                <a:solidFill>
+                  <a:srgbClr val="1A1A2E"/>
+                </a:solidFill>
+              </a:rPr>
+              <a:t>× </a:t>
+            </a:r>
+            <a:r>
+              <a:rPr lang="en-IN" sz="1400" b="0" i="0" dirty="0">
+                <a:solidFill>
+                  <a:srgbClr val="1A1A2E"/>
+                </a:solidFill>
+              </a:rPr>
+              <a:t>SG90</a:t>
+            </a:r>
+            <a:r>
+              <a:rPr sz="1400" b="0" i="0" dirty="0">
+                <a:solidFill>
+                  <a:srgbClr val="1A1A2E"/>
+                </a:solidFill>
+              </a:rPr>
+              <a:t>S servos</a:t>
             </a:r>
           </a:p>
         </p:txBody>
@@ -30303,7 +29553,7 @@
         <p:spPr>
           <a:xfrm>
             <a:off x="822960" y="2724912"/>
-            <a:ext cx="10881360" cy="402336"/>
+            <a:ext cx="10881360" cy="307777"/>
           </a:xfrm>
           <a:prstGeom prst="rect">
             <a:avLst/>
@@ -30318,12 +29568,28 @@
           <a:p>
             <a:pPr algn="l"/>
             <a:r>
-              <a:rPr sz="1400" b="0" i="0">
+              <a:rPr sz="1400" b="0" i="0" dirty="0">
                 <a:solidFill>
                   <a:srgbClr val="1A1A2E"/>
                 </a:solidFill>
               </a:rPr>
-              <a:t>Chassis designed in FreeCAD — fabricated with FDM 3D printing (PLA+ &amp; PETG)</a:t>
+              <a:t>Chassis designed in FreeCAD — fabricated with FDM 3D printing (PLA+ &amp; </a:t>
+            </a:r>
+            <a:r>
+              <a:rPr lang="en-IN" sz="1400" b="0" i="0" dirty="0">
+                <a:solidFill>
+                  <a:srgbClr val="1A1A2E"/>
+                </a:solidFill>
+              </a:rPr>
+              <a:t>ABS</a:t>
+            </a:r>
+            <a:r>
+              <a:rPr sz="1400" b="0" i="0" dirty="0">
+                <a:solidFill>
+                  <a:srgbClr val="1A1A2E"/>
+                </a:solidFill>
+              </a:rPr>
+              <a:t>)</a:t>
             </a:r>
           </a:p>
         </p:txBody>
@@ -30600,6 +29866,42 @@
           </a:p>
         </p:txBody>
       </p:sp>
+      <p:pic>
+        <p:nvPicPr>
+          <p:cNvPr id="28" name="Graphic 27">
+            <a:extLst>
+              <a:ext uri="{FF2B5EF4-FFF2-40B4-BE49-F238E27FC236}">
+                <a16:creationId xmlns:a16="http://schemas.microsoft.com/office/drawing/2014/main" id="{A4D4C370-C43E-A9E6-0B05-6230BA1ACC1A}"/>
+              </a:ext>
+            </a:extLst>
+          </p:cNvPr>
+          <p:cNvPicPr>
+            <a:picLocks noChangeAspect="1"/>
+          </p:cNvPicPr>
+          <p:nvPr/>
+        </p:nvPicPr>
+        <p:blipFill>
+          <a:blip r:embed="rId2">
+            <a:extLst>
+              <a:ext uri="{96DAC541-7B7A-43D3-8B79-37D633B846F1}">
+                <asvg:svgBlip xmlns:asvg="http://schemas.microsoft.com/office/drawing/2016/SVG/main" r:embed="rId3"/>
+              </a:ext>
+            </a:extLst>
+          </a:blip>
+          <a:stretch>
+            <a:fillRect/>
+          </a:stretch>
+        </p:blipFill>
+        <p:spPr>
+          <a:xfrm>
+            <a:off x="7350929" y="1452770"/>
+            <a:ext cx="4595707" cy="4190203"/>
+          </a:xfrm>
+          <a:prstGeom prst="rect">
+            <a:avLst/>
+          </a:prstGeom>
+        </p:spPr>
+      </p:pic>
     </p:spTree>
   </p:cSld>
   <p:clrMapOvr>
@@ -31194,7 +30496,7 @@
         <p:spPr>
           <a:xfrm>
             <a:off x="822960" y="2770632"/>
-            <a:ext cx="6583680" cy="402336"/>
+            <a:ext cx="6583680" cy="307777"/>
           </a:xfrm>
           <a:prstGeom prst="rect">
             <a:avLst/>
@@ -31209,12 +30511,12 @@
           <a:p>
             <a:pPr algn="l"/>
             <a:r>
-              <a:rPr sz="1400" b="0" i="0">
+              <a:rPr sz="1400" b="0" i="0" dirty="0">
                 <a:solidFill>
                   <a:srgbClr val="1A1A2E"/>
                 </a:solidFill>
               </a:rPr>
-              <a:t>This robot: Hip joint + Knee joint per leg → 8 DOF for locomotion + 1 DOF head rotation</a:t>
+              <a:t>This robot: Hip joint + Knee joint per leg → 8 DOF for locomotion</a:t>
             </a:r>
           </a:p>
         </p:txBody>
@@ -31355,7 +30657,7 @@
           <a:p>
             <a:pPr algn="ctr"/>
             <a:r>
-              <a:rPr sz="2800" b="1" i="0">
+              <a:rPr sz="2800" b="1" i="0" dirty="0">
                 <a:solidFill>
                   <a:srgbClr val="F5C518"/>
                 </a:solidFill>
@@ -31453,28 +30755,33 @@
         <p:spPr>
           <a:xfrm>
             <a:off x="3291839" y="4663440"/>
-            <a:ext cx="2377440" cy="640080"/>
-          </a:xfrm>
-          <a:prstGeom prst="rect">
-            <a:avLst/>
-          </a:prstGeom>
-          <a:noFill/>
-        </p:spPr>
-        <p:txBody>
-          <a:bodyPr wrap="square">
-            <a:spAutoFit/>
-          </a:bodyPr>
-          <a:lstStyle/>
-          <a:p>
-            <a:pPr algn="ctr"/>
-            <a:r>
-              <a:rPr sz="2800" b="1" i="0">
+            <a:ext cx="2377440" cy="523220"/>
+          </a:xfrm>
+          <a:prstGeom prst="rect">
+            <a:avLst/>
+          </a:prstGeom>
+          <a:noFill/>
+        </p:spPr>
+        <p:txBody>
+          <a:bodyPr wrap="square">
+            <a:spAutoFit/>
+          </a:bodyPr>
+          <a:lstStyle/>
+          <a:p>
+            <a:pPr algn="ctr"/>
+            <a:r>
+              <a:rPr lang="en-IN" sz="2800" b="1" i="0" dirty="0">
                 <a:solidFill>
                   <a:srgbClr val="F5C518"/>
                 </a:solidFill>
               </a:rPr>
-              <a:t>1 DOF</a:t>
-            </a:r>
+              <a:t>Static Head</a:t>
+            </a:r>
+            <a:endParaRPr sz="2800" b="1" i="0" dirty="0">
+              <a:solidFill>
+                <a:srgbClr val="F5C518"/>
+              </a:solidFill>
+            </a:endParaRPr>
           </a:p>
         </p:txBody>
       </p:sp>
@@ -31487,29 +30794,58 @@
         <p:spPr>
           <a:xfrm>
             <a:off x="3291839" y="5285232"/>
-            <a:ext cx="2377440" cy="868680"/>
-          </a:xfrm>
-          <a:prstGeom prst="rect">
-            <a:avLst/>
-          </a:prstGeom>
-          <a:noFill/>
-        </p:spPr>
-        <p:txBody>
-          <a:bodyPr wrap="square">
-            <a:spAutoFit/>
-          </a:bodyPr>
-          <a:lstStyle/>
-          <a:p>
-            <a:pPr algn="ctr"/>
-            <a:r>
-              <a:rPr sz="1200" b="0" i="0">
+            <a:ext cx="2377440" cy="461665"/>
+          </a:xfrm>
+          <a:prstGeom prst="rect">
+            <a:avLst/>
+          </a:prstGeom>
+          <a:noFill/>
+        </p:spPr>
+        <p:txBody>
+          <a:bodyPr wrap="square">
+            <a:spAutoFit/>
+          </a:bodyPr>
+          <a:lstStyle/>
+          <a:p>
+            <a:pPr algn="ctr"/>
+            <a:r>
+              <a:rPr sz="1200" b="0" i="0" dirty="0">
                 <a:solidFill>
                   <a:srgbClr val="FFFFFF"/>
                 </a:solidFill>
               </a:rPr>
               <a:t>Head
-Rotation</a:t>
-            </a:r>
+</a:t>
+            </a:r>
+            <a:r>
+              <a:rPr lang="en-US" sz="1200" b="0" i="0" dirty="0">
+                <a:solidFill>
+                  <a:srgbClr val="FFFFFF"/>
+                </a:solidFill>
+              </a:rPr>
+              <a:t>is </a:t>
+            </a:r>
+            <a:r>
+              <a:rPr lang="en-US" sz="1200" dirty="0">
+                <a:solidFill>
+                  <a:srgbClr val="FFFFFF"/>
+                </a:solidFill>
+              </a:rPr>
+              <a:t>s</a:t>
+            </a:r>
+            <a:r>
+              <a:rPr lang="en-US" sz="1200" b="0" i="0" dirty="0">
+                <a:solidFill>
+                  <a:srgbClr val="FFFFFF"/>
+                </a:solidFill>
+              </a:rPr>
+              <a:t>tationary</a:t>
+            </a:r>
+            <a:endParaRPr sz="1200" b="0" i="0" dirty="0">
+              <a:solidFill>
+                <a:srgbClr val="FFFFFF"/>
+              </a:solidFill>
+            </a:endParaRPr>
           </a:p>
         </p:txBody>
       </p:sp>
@@ -31566,27 +30902,35 @@
         <p:spPr>
           <a:xfrm>
             <a:off x="6080759" y="4663440"/>
-            <a:ext cx="2377440" cy="640080"/>
-          </a:xfrm>
-          <a:prstGeom prst="rect">
-            <a:avLst/>
-          </a:prstGeom>
-          <a:noFill/>
-        </p:spPr>
-        <p:txBody>
-          <a:bodyPr wrap="square">
-            <a:spAutoFit/>
-          </a:bodyPr>
-          <a:lstStyle/>
-          <a:p>
-            <a:pPr algn="ctr"/>
-            <a:r>
-              <a:rPr sz="2800" b="1" i="0">
+            <a:ext cx="2377440" cy="523220"/>
+          </a:xfrm>
+          <a:prstGeom prst="rect">
+            <a:avLst/>
+          </a:prstGeom>
+          <a:noFill/>
+        </p:spPr>
+        <p:txBody>
+          <a:bodyPr wrap="square">
+            <a:spAutoFit/>
+          </a:bodyPr>
+          <a:lstStyle/>
+          <a:p>
+            <a:pPr algn="ctr"/>
+            <a:r>
+              <a:rPr lang="en-US" sz="2800" b="1" i="0" dirty="0">
                 <a:solidFill>
                   <a:srgbClr val="F5C518"/>
                 </a:solidFill>
               </a:rPr>
-              <a:t>9 Total</a:t>
+              <a:t>8</a:t>
+            </a:r>
+            <a:r>
+              <a:rPr sz="2800" b="1" i="0" dirty="0">
+                <a:solidFill>
+                  <a:srgbClr val="F5C518"/>
+                </a:solidFill>
+              </a:rPr>
+              <a:t> Total</a:t>
             </a:r>
           </a:p>
         </p:txBody>
@@ -31600,27 +30944,35 @@
         <p:spPr>
           <a:xfrm>
             <a:off x="6080759" y="5285232"/>
-            <a:ext cx="2377440" cy="868680"/>
-          </a:xfrm>
-          <a:prstGeom prst="rect">
-            <a:avLst/>
-          </a:prstGeom>
-          <a:noFill/>
-        </p:spPr>
-        <p:txBody>
-          <a:bodyPr wrap="square">
-            <a:spAutoFit/>
-          </a:bodyPr>
-          <a:lstStyle/>
-          <a:p>
-            <a:pPr algn="ctr"/>
-            <a:r>
-              <a:rPr sz="1200" b="0" i="0">
+            <a:ext cx="2377440" cy="461665"/>
+          </a:xfrm>
+          <a:prstGeom prst="rect">
+            <a:avLst/>
+          </a:prstGeom>
+          <a:noFill/>
+        </p:spPr>
+        <p:txBody>
+          <a:bodyPr wrap="square">
+            <a:spAutoFit/>
+          </a:bodyPr>
+          <a:lstStyle/>
+          <a:p>
+            <a:pPr algn="ctr"/>
+            <a:r>
+              <a:rPr lang="en-IN" sz="1200" b="0" i="0" dirty="0">
                 <a:solidFill>
                   <a:srgbClr val="FFFFFF"/>
                 </a:solidFill>
               </a:rPr>
-              <a:t>MG90S
+              <a:t>SG90</a:t>
+            </a:r>
+            <a:r>
+              <a:rPr sz="1200" b="0" i="0" dirty="0">
+                <a:solidFill>
+                  <a:srgbClr val="FFFFFF"/>
+                </a:solidFill>
+              </a:rPr>
+              <a:t>S
 Servos</a:t>
             </a:r>
           </a:p>
@@ -33941,7 +33293,7 @@
         <p:spPr>
           <a:xfrm>
             <a:off x="6766560" y="3255263"/>
-            <a:ext cx="4892040" cy="402336"/>
+            <a:ext cx="4892040" cy="276999"/>
           </a:xfrm>
           <a:prstGeom prst="rect">
             <a:avLst/>
@@ -33956,12 +33308,28 @@
           <a:p>
             <a:pPr algn="l"/>
             <a:r>
-              <a:rPr sz="1200" b="0" i="0">
+              <a:rPr sz="1200" b="0" i="0" dirty="0">
                 <a:solidFill>
                   <a:srgbClr val="1A1A2E"/>
                 </a:solidFill>
               </a:rPr>
-              <a:t>PLA+ → structural rigidity for Core Plate &amp; Head Box</a:t>
+              <a:t>PLA+ → structural rigidity for </a:t>
+            </a:r>
+            <a:r>
+              <a:rPr lang="en-IN" sz="1200" b="0" i="0" dirty="0">
+                <a:solidFill>
+                  <a:srgbClr val="1A1A2E"/>
+                </a:solidFill>
+              </a:rPr>
+              <a:t>Core Body</a:t>
+            </a:r>
+            <a:r>
+              <a:rPr sz="1200" b="0" i="0" dirty="0">
+                <a:solidFill>
+                  <a:srgbClr val="1A1A2E"/>
+                </a:solidFill>
+              </a:rPr>
+              <a:t> &amp; Head Box</a:t>
             </a:r>
           </a:p>
         </p:txBody>
@@ -34009,7 +33377,7 @@
         <p:spPr>
           <a:xfrm>
             <a:off x="6766560" y="3685031"/>
-            <a:ext cx="4892040" cy="402336"/>
+            <a:ext cx="4892040" cy="276999"/>
           </a:xfrm>
           <a:prstGeom prst="rect">
             <a:avLst/>
@@ -34024,12 +33392,20 @@
           <a:p>
             <a:pPr algn="l"/>
             <a:r>
-              <a:rPr sz="1200" b="0" i="0">
+              <a:rPr lang="en-IN" sz="1200" b="0" i="0" dirty="0">
                 <a:solidFill>
                   <a:srgbClr val="1A1A2E"/>
                 </a:solidFill>
               </a:rPr>
-              <a:t>PETG → flexibility &amp; impact resistance for leg links</a:t>
+              <a:t>ABS</a:t>
+            </a:r>
+            <a:r>
+              <a:rPr sz="1200" b="0" i="0" dirty="0">
+                <a:solidFill>
+                  <a:srgbClr val="1A1A2E"/>
+                </a:solidFill>
+              </a:rPr>
+              <a:t> → flexibility &amp; impact resistance for leg links</a:t>
             </a:r>
           </a:p>
         </p:txBody>
@@ -34146,6 +33522,84 @@
           </a:p>
         </p:txBody>
       </p:sp>
+      <p:pic>
+        <p:nvPicPr>
+          <p:cNvPr id="1026" name="Picture 2" descr="SquadPixel Esp-32 Wifi, Bluetooth, Dual Core Chip Development Board  (ESP-WROOM-32) : Amazon.in: Fashion">
+            <a:extLst>
+              <a:ext uri="{FF2B5EF4-FFF2-40B4-BE49-F238E27FC236}">
+                <a16:creationId xmlns:a16="http://schemas.microsoft.com/office/drawing/2014/main" id="{2689DE3E-6960-D760-F4E4-681304E890A1}"/>
+              </a:ext>
+            </a:extLst>
+          </p:cNvPr>
+          <p:cNvPicPr>
+            <a:picLocks noChangeAspect="1" noChangeArrowheads="1"/>
+          </p:cNvPicPr>
+          <p:nvPr/>
+        </p:nvPicPr>
+        <p:blipFill>
+          <a:blip r:embed="rId2">
+            <a:extLst>
+              <a:ext uri="{28A0092B-C50C-407E-A947-70E740481C1C}">
+                <a14:useLocalDpi xmlns:a14="http://schemas.microsoft.com/office/drawing/2010/main" val="0"/>
+              </a:ext>
+            </a:extLst>
+          </a:blip>
+          <a:srcRect/>
+          <a:stretch>
+            <a:fillRect/>
+          </a:stretch>
+        </p:blipFill>
+        <p:spPr bwMode="auto">
+          <a:xfrm>
+            <a:off x="1314280" y="4517136"/>
+            <a:ext cx="3202475" cy="1873770"/>
+          </a:xfrm>
+          <a:prstGeom prst="rect">
+            <a:avLst/>
+          </a:prstGeom>
+          <a:noFill/>
+          <a:extLst>
+            <a:ext uri="{909E8E84-426E-40DD-AFC4-6F175D3DCCD1}">
+              <a14:hiddenFill xmlns:a14="http://schemas.microsoft.com/office/drawing/2010/main">
+                <a:solidFill>
+                  <a:srgbClr val="FFFFFF"/>
+                </a:solidFill>
+              </a14:hiddenFill>
+            </a:ext>
+          </a:extLst>
+        </p:spPr>
+      </p:pic>
+      <p:pic>
+        <p:nvPicPr>
+          <p:cNvPr id="42" name="Picture 41">
+            <a:extLst>
+              <a:ext uri="{FF2B5EF4-FFF2-40B4-BE49-F238E27FC236}">
+                <a16:creationId xmlns:a16="http://schemas.microsoft.com/office/drawing/2014/main" id="{5F589037-75E6-4E43-867C-653090F10C29}"/>
+              </a:ext>
+            </a:extLst>
+          </p:cNvPr>
+          <p:cNvPicPr>
+            <a:picLocks noChangeAspect="1"/>
+          </p:cNvPicPr>
+          <p:nvPr/>
+        </p:nvPicPr>
+        <p:blipFill>
+          <a:blip r:embed="rId3"/>
+          <a:srcRect b="9333"/>
+          <a:stretch>
+            <a:fillRect/>
+          </a:stretch>
+        </p:blipFill>
+        <p:spPr>
+          <a:xfrm>
+            <a:off x="7717949" y="4513658"/>
+            <a:ext cx="2760662" cy="1877248"/>
+          </a:xfrm>
+          <a:prstGeom prst="rect">
+            <a:avLst/>
+          </a:prstGeom>
+        </p:spPr>
+      </p:pic>
     </p:spTree>
   </p:cSld>
   <p:clrMapOvr>
@@ -37149,7 +36603,7 @@
         <p:spPr>
           <a:xfrm>
             <a:off x="502920" y="3849624"/>
-            <a:ext cx="7589520" cy="384048"/>
+            <a:ext cx="7589520" cy="276999"/>
           </a:xfrm>
           <a:prstGeom prst="rect">
             <a:avLst/>
@@ -37164,12 +36618,36 @@
           <a:p>
             <a:pPr algn="l"/>
             <a:r>
-              <a:rPr sz="1200" b="0" i="0">
+              <a:rPr lang="en-US" sz="1200" b="0" i="0" dirty="0">
                 <a:solidFill>
                   <a:srgbClr val="FFFFFF"/>
                 </a:solidFill>
               </a:rPr>
-              <a:t>9× MG90S Metal Gear Micro Servos  (4 Hip + 4 Knee + 1 Head)</a:t>
+              <a:t>8</a:t>
+            </a:r>
+            <a:r>
+              <a:rPr sz="1200" b="0" i="0" dirty="0">
+                <a:solidFill>
+                  <a:srgbClr val="FFFFFF"/>
+                </a:solidFill>
+              </a:rPr>
+              <a:t>× </a:t>
+            </a:r>
+            <a:r>
+              <a:rPr lang="en-IN" sz="1200" b="0" i="0" dirty="0">
+                <a:solidFill>
+                  <a:srgbClr val="FFFFFF"/>
+                </a:solidFill>
+              </a:rPr>
+              <a:t>SG90</a:t>
+            </a:r>
+            <a:r>
+              <a:rPr sz="1200" b="0" i="0" dirty="0">
+                <a:solidFill>
+                  <a:srgbClr val="FFFFFF"/>
+                </a:solidFill>
+              </a:rPr>
+              <a:t>S Metal Gear Micro Servos  (4 Hip + 4 Knee)</a:t>
             </a:r>
           </a:p>
         </p:txBody>
@@ -38481,7 +37959,7 @@
         <p:spPr>
           <a:xfrm>
             <a:off x="320040" y="749808"/>
-            <a:ext cx="10972800" cy="411480"/>
+            <a:ext cx="10972800" cy="307777"/>
           </a:xfrm>
           <a:prstGeom prst="rect">
             <a:avLst/>
@@ -38496,12 +37974,60 @@
           <a:p>
             <a:pPr algn="l"/>
             <a:r>
-              <a:rPr sz="1400" b="0" i="0">
+              <a:rPr sz="1400" b="0" i="0" dirty="0">
                 <a:solidFill>
                   <a:srgbClr val="F5C518"/>
                 </a:solidFill>
               </a:rPr>
-              <a:t>PCA9685 CH0–CH8 → 9 MG90S servos</a:t>
+              <a:t>PCA9685 CH0–CH</a:t>
+            </a:r>
+            <a:r>
+              <a:rPr lang="en-US" sz="1400" b="0" i="0" dirty="0">
+                <a:solidFill>
+                  <a:srgbClr val="F5C518"/>
+                </a:solidFill>
+              </a:rPr>
+              <a:t>7</a:t>
+            </a:r>
+            <a:r>
+              <a:rPr sz="1400" b="0" i="0" dirty="0">
+                <a:solidFill>
+                  <a:srgbClr val="F5C518"/>
+                </a:solidFill>
+              </a:rPr>
+              <a:t> → </a:t>
+            </a:r>
+            <a:r>
+              <a:rPr lang="en-US" sz="1400" b="0" i="0" dirty="0">
+                <a:solidFill>
+                  <a:srgbClr val="F5C518"/>
+                </a:solidFill>
+              </a:rPr>
+              <a:t>8</a:t>
+            </a:r>
+            <a:r>
+              <a:rPr sz="1400" b="0" i="0" dirty="0">
+                <a:solidFill>
+                  <a:srgbClr val="F5C518"/>
+                </a:solidFill>
+              </a:rPr>
+              <a:t> </a:t>
+            </a:r>
+            <a:r>
+              <a:rPr lang="en-IN" sz="1400" b="0" i="0" dirty="0">
+                <a:solidFill>
+                  <a:srgbClr val="F5C518"/>
+                </a:solidFill>
+              </a:rPr>
+              <a:t>SG90</a:t>
+            </a:r>
+            <a:r>
+              <a:rPr sz="1400" b="0" i="0" dirty="0">
+                <a:solidFill>
+                  <a:srgbClr val="F5C518"/>
+                </a:solidFill>
+              </a:rPr>
+              <a:t>S servos</a:t>
             </a:r>
           </a:p>
         </p:txBody>
@@ -40134,196 +39660,6 @@
                 </a:solidFill>
               </a:rPr>
               <a:t>Type: Knee</a:t>
-            </a:r>
-          </a:p>
-        </p:txBody>
-      </p:sp>
-      <p:sp>
-        <p:nvSpPr>
-          <p:cNvPr id="51" name="Rectangle 50"/>
-          <p:cNvSpPr/>
-          <p:nvPr/>
-        </p:nvSpPr>
-        <p:spPr>
-          <a:xfrm>
-            <a:off x="6309360" y="4069079"/>
-            <a:ext cx="914400" cy="749808"/>
-          </a:xfrm>
-          <a:prstGeom prst="rect">
-            <a:avLst/>
-          </a:prstGeom>
-          <a:solidFill>
-            <a:srgbClr val="277E4A"/>
-          </a:solidFill>
-          <a:ln>
-            <a:noFill/>
-          </a:ln>
-        </p:spPr>
-        <p:style>
-          <a:lnRef idx="1">
-            <a:schemeClr val="accent1"/>
-          </a:lnRef>
-          <a:fillRef idx="3">
-            <a:schemeClr val="accent1"/>
-          </a:fillRef>
-          <a:effectRef idx="2">
-            <a:schemeClr val="accent1"/>
-          </a:effectRef>
-          <a:fontRef idx="minor">
-            <a:schemeClr val="lt1"/>
-          </a:fontRef>
-        </p:style>
-        <p:txBody>
-          <a:bodyPr rtlCol="0" anchor="ctr"/>
-          <a:lstStyle/>
-          <a:p>
-            <a:pPr algn="ctr"/>
-            <a:endParaRPr/>
-          </a:p>
-        </p:txBody>
-      </p:sp>
-      <p:sp>
-        <p:nvSpPr>
-          <p:cNvPr id="52" name="TextBox 51"/>
-          <p:cNvSpPr txBox="1"/>
-          <p:nvPr/>
-        </p:nvSpPr>
-        <p:spPr>
-          <a:xfrm>
-            <a:off x="6345936" y="4114799"/>
-            <a:ext cx="841248" cy="658368"/>
-          </a:xfrm>
-          <a:prstGeom prst="rect">
-            <a:avLst/>
-          </a:prstGeom>
-          <a:noFill/>
-        </p:spPr>
-        <p:txBody>
-          <a:bodyPr wrap="square">
-            <a:spAutoFit/>
-          </a:bodyPr>
-          <a:lstStyle/>
-          <a:p>
-            <a:pPr algn="ctr"/>
-            <a:r>
-              <a:rPr sz="1800" b="1" i="0">
-                <a:solidFill>
-                  <a:srgbClr val="FFFFFF"/>
-                </a:solidFill>
-              </a:rPr>
-              <a:t>CH8</a:t>
-            </a:r>
-          </a:p>
-        </p:txBody>
-      </p:sp>
-      <p:sp>
-        <p:nvSpPr>
-          <p:cNvPr id="53" name="Rectangle 52"/>
-          <p:cNvSpPr/>
-          <p:nvPr/>
-        </p:nvSpPr>
-        <p:spPr>
-          <a:xfrm>
-            <a:off x="7269480" y="4069079"/>
-            <a:ext cx="4663440" cy="749808"/>
-          </a:xfrm>
-          <a:prstGeom prst="rect">
-            <a:avLst/>
-          </a:prstGeom>
-          <a:solidFill>
-            <a:srgbClr val="E8F0FB"/>
-          </a:solidFill>
-          <a:ln>
-            <a:noFill/>
-          </a:ln>
-        </p:spPr>
-        <p:style>
-          <a:lnRef idx="1">
-            <a:schemeClr val="accent1"/>
-          </a:lnRef>
-          <a:fillRef idx="3">
-            <a:schemeClr val="accent1"/>
-          </a:fillRef>
-          <a:effectRef idx="2">
-            <a:schemeClr val="accent1"/>
-          </a:effectRef>
-          <a:fontRef idx="minor">
-            <a:schemeClr val="lt1"/>
-          </a:fontRef>
-        </p:style>
-        <p:txBody>
-          <a:bodyPr rtlCol="0" anchor="ctr"/>
-          <a:lstStyle/>
-          <a:p>
-            <a:pPr algn="ctr"/>
-            <a:endParaRPr/>
-          </a:p>
-        </p:txBody>
-      </p:sp>
-      <p:sp>
-        <p:nvSpPr>
-          <p:cNvPr id="54" name="TextBox 53"/>
-          <p:cNvSpPr txBox="1"/>
-          <p:nvPr/>
-        </p:nvSpPr>
-        <p:spPr>
-          <a:xfrm>
-            <a:off x="7360920" y="4123943"/>
-            <a:ext cx="4480560" cy="329184"/>
-          </a:xfrm>
-          <a:prstGeom prst="rect">
-            <a:avLst/>
-          </a:prstGeom>
-          <a:noFill/>
-        </p:spPr>
-        <p:txBody>
-          <a:bodyPr wrap="square">
-            <a:spAutoFit/>
-          </a:bodyPr>
-          <a:lstStyle/>
-          <a:p>
-            <a:pPr algn="l"/>
-            <a:r>
-              <a:rPr sz="1400" b="1" i="0">
-                <a:solidFill>
-                  <a:srgbClr val="1A1A2E"/>
-                </a:solidFill>
-              </a:rPr>
-              <a:t>Head Rotation</a:t>
-            </a:r>
-          </a:p>
-        </p:txBody>
-      </p:sp>
-      <p:sp>
-        <p:nvSpPr>
-          <p:cNvPr id="55" name="TextBox 54"/>
-          <p:cNvSpPr txBox="1"/>
-          <p:nvPr/>
-        </p:nvSpPr>
-        <p:spPr>
-          <a:xfrm>
-            <a:off x="7360920" y="4453127"/>
-            <a:ext cx="4480560" cy="292608"/>
-          </a:xfrm>
-          <a:prstGeom prst="rect">
-            <a:avLst/>
-          </a:prstGeom>
-          <a:noFill/>
-        </p:spPr>
-        <p:txBody>
-          <a:bodyPr wrap="square">
-            <a:spAutoFit/>
-          </a:bodyPr>
-          <a:lstStyle/>
-          <a:p>
-            <a:pPr algn="l"/>
-            <a:r>
-              <a:rPr sz="1100" b="0" i="0">
-                <a:solidFill>
-                  <a:srgbClr val="277E4A"/>
-                </a:solidFill>
-              </a:rPr>
-              <a:t>Type: Head</a:t>
             </a:r>
           </a:p>
         </p:txBody>

</xml_diff>